<commit_message>
Security fix: hide v6 manager + v7 superseded dashboards (prefix match catches dated archives)
</commit_message>
<xml_diff>
--- a/generated/Sales Dashboards/BD Rep Scoreboard.pptx
+++ b/generated/Sales Dashboards/BD Rep Scoreboard.pptx
@@ -578,7 +578,7 @@
           </a:p>
           <a:p>
             <a:r>
-              <a:t>- YTD chart: total company GWP per month (new business + renewals + endorsements) for each month of 2026.</a:t>
+              <a:t>- YTD chart: total company Production per month (New + Renewal + Endorsement) for each month of 2026. GWP elsewhere on the deck is net of Cancellations and Reinstatements per Nyles's definition; Production is the gross "what was written" view used here.</a:t>
             </a:r>
           </a:p>
           <a:p/>
@@ -5019,7 +5019,7 @@
               </a:defRPr>
             </a:pPr>
             <a:r>
-              <a:t>$37.2M</a:t>
+              <a:t>$17.2M</a:t>
             </a:r>
           </a:p>
         </p:txBody>
@@ -5055,7 +5055,7 @@
               </a:defRPr>
             </a:pPr>
             <a:r>
-              <a:t>Team GWP Q2 YTD  |  Proj. $70.4M</a:t>
+              <a:t>Team GWP Q2 YTD  |  Proj. $32.7M</a:t>
             </a:r>
           </a:p>
         </p:txBody>
@@ -5134,7 +5134,7 @@
               </a:defRPr>
             </a:pPr>
             <a:r>
-              <a:t>Pacing 116% of Q1 Final</a:t>
+              <a:t>Pacing 177% of Q1 Final</a:t>
             </a:r>
           </a:p>
         </p:txBody>
@@ -5752,13 +5752,13 @@
             <a:pPr algn="ctr">
               <a:defRPr sz="900" b="1">
                 <a:solidFill>
-                  <a:srgbClr val="DC2626"/>
-                </a:solidFill>
-                <a:latin typeface="Calibri"/>
-              </a:defRPr>
-            </a:pPr>
-            <a:r>
-              <a:t>▼ $2.3M vs Apr pace</a:t>
+                  <a:srgbClr val="059669"/>
+                </a:solidFill>
+                <a:latin typeface="Calibri"/>
+              </a:defRPr>
+            </a:pPr>
+            <a:r>
+              <a:t>▲ $3.1M vs Apr pace</a:t>
             </a:r>
           </a:p>
         </p:txBody>
@@ -6107,7 +6107,7 @@
               </a:defRPr>
             </a:pPr>
             <a:r>
-              <a:t>New Business (64%)</a:t>
+              <a:t>New Business (70%)</a:t>
             </a:r>
           </a:p>
         </p:txBody>
@@ -6179,7 +6179,7 @@
               </a:defRPr>
             </a:pPr>
             <a:r>
-              <a:t>Renewals (20%)</a:t>
+              <a:t>Renewals (22%)</a:t>
             </a:r>
           </a:p>
         </p:txBody>
@@ -6215,7 +6215,7 @@
               </a:defRPr>
             </a:pPr>
             <a:r>
-              <a:t>$5.7M</a:t>
+              <a:t>$2.7M</a:t>
             </a:r>
           </a:p>
         </p:txBody>
@@ -6251,7 +6251,7 @@
               </a:defRPr>
             </a:pPr>
             <a:r>
-              <a:t>Endorsements (15%)</a:t>
+              <a:t>Endorsements (8%)</a:t>
             </a:r>
           </a:p>
         </p:txBody>
@@ -6456,7 +6456,7 @@
               </a:defRPr>
             </a:pPr>
             <a:r>
-              <a:t>$60.8M</a:t>
+              <a:t>$18.4M</a:t>
             </a:r>
           </a:p>
         </p:txBody>
@@ -6787,7 +6787,7 @@
               </a:defRPr>
             </a:pPr>
             <a:r>
-              <a:t>MTD (May):  $12.80M written  ·  $22.04M pace  ·  18/31 days elapsed</a:t>
+              <a:t>MTD (May):  $7.47M written  ·  $12.86M pace  ·  18/31 days elapsed</a:t>
             </a:r>
           </a:p>
         </p:txBody>
@@ -21984,7 +21984,7 @@
               </a:defRPr>
             </a:pPr>
             <a:r>
-              <a:t>10</a:t>
+              <a:t>11</a:t>
             </a:r>
           </a:p>
         </p:txBody>
@@ -25376,7 +25376,7 @@
               </a:defRPr>
             </a:pPr>
             <a:r>
-              <a:t>188</a:t>
+              <a:t>189</a:t>
             </a:r>
           </a:p>
         </p:txBody>
@@ -25484,7 +25484,7 @@
               </a:defRPr>
             </a:pPr>
             <a:r>
-              <a:t>211</a:t>
+              <a:t>212</a:t>
             </a:r>
           </a:p>
         </p:txBody>
@@ -26067,7 +26067,7 @@
               </a:defRPr>
             </a:pPr>
             <a:r>
-              <a:t>43</a:t>
+              <a:t>44</a:t>
             </a:r>
           </a:p>
         </p:txBody>
@@ -28523,7 +28523,7 @@
               </a:defRPr>
             </a:pPr>
             <a:r>
-              <a:t>10</a:t>
+              <a:t>11</a:t>
             </a:r>
           </a:p>
         </p:txBody>
@@ -28559,7 +28559,7 @@
               </a:defRPr>
             </a:pPr>
             <a:r>
-              <a:t>56%</a:t>
+              <a:t>57%</a:t>
             </a:r>
           </a:p>
         </p:txBody>
@@ -31103,7 +31103,7 @@
               </a:defRPr>
             </a:pPr>
             <a:r>
-              <a:t>134</a:t>
+              <a:t>135</a:t>
             </a:r>
           </a:p>
         </p:txBody>
@@ -31211,7 +31211,7 @@
               </a:defRPr>
             </a:pPr>
             <a:r>
-              <a:t>141</a:t>
+              <a:t>142</a:t>
             </a:r>
           </a:p>
         </p:txBody>
@@ -31247,7 +31247,7 @@
               </a:defRPr>
             </a:pPr>
             <a:r>
-              <a:t>28.2</a:t>
+              <a:t>28.4</a:t>
             </a:r>
           </a:p>
         </p:txBody>
@@ -31283,7 +31283,7 @@
               </a:defRPr>
             </a:pPr>
             <a:r>
-              <a:t>56%</a:t>
+              <a:t>57%</a:t>
             </a:r>
           </a:p>
         </p:txBody>

</xml_diff>

<commit_message>
Home page: CW Championship Belts row (Derek Janssen Q1 Activity, Belt #2 vacant)
</commit_message>
<xml_diff>
--- a/generated/Sales Dashboards/BD Rep Scoreboard.pptx
+++ b/generated/Sales Dashboards/BD Rep Scoreboard.pptx
@@ -23277,7 +23277,7 @@
               </a:defRPr>
             </a:pPr>
             <a:r>
-              <a:t>12</a:t>
+              <a:t>13</a:t>
             </a:r>
           </a:p>
         </p:txBody>
@@ -25995,7 +25995,7 @@
               </a:defRPr>
             </a:pPr>
             <a:r>
-              <a:t>370</a:t>
+              <a:t>371</a:t>
             </a:r>
           </a:p>
         </p:txBody>
@@ -26103,7 +26103,7 @@
               </a:defRPr>
             </a:pPr>
             <a:r>
-              <a:t>389</a:t>
+              <a:t>390</a:t>
             </a:r>
           </a:p>
         </p:txBody>
@@ -29076,7 +29076,7 @@
               </a:defRPr>
             </a:pPr>
             <a:r>
-              <a:t>17</a:t>
+              <a:t>18</a:t>
             </a:r>
           </a:p>
         </p:txBody>
@@ -31391,7 +31391,7 @@
               </a:defRPr>
             </a:pPr>
             <a:r>
-              <a:t>170</a:t>
+              <a:t>171</a:t>
             </a:r>
           </a:p>
         </p:txBody>
@@ -31499,7 +31499,7 @@
               </a:defRPr>
             </a:pPr>
             <a:r>
-              <a:t>180</a:t>
+              <a:t>181</a:t>
             </a:r>
           </a:p>
         </p:txBody>
@@ -31535,7 +31535,7 @@
               </a:defRPr>
             </a:pPr>
             <a:r>
-              <a:t>36.0</a:t>
+              <a:t>36.2</a:t>
             </a:r>
           </a:p>
         </p:txBody>

</xml_diff>

<commit_message>
Daily rebuild Sun 05/24/2026  5:32:08.17
</commit_message>
<xml_diff>
--- a/generated/Sales Dashboards/BD Rep Scoreboard.pptx
+++ b/generated/Sales Dashboards/BD Rep Scoreboard.pptx
@@ -1661,7 +1661,7 @@
           </a:p>
           <a:p>
             <a:r>
-              <a:t>- We are 53 days into a 91-day quarter.</a:t>
+              <a:t>- We are 54 days into a 91-day quarter.</a:t>
             </a:r>
           </a:p>
         </p:txBody>
@@ -4902,7 +4902,7 @@
               </a:defRPr>
             </a:pPr>
             <a:r>
-              <a:t>As of May 23, 2026  |  53 days into Q2  |  38 days remaining</a:t>
+              <a:t>As of May 24, 2026  |  54 days into Q2  |  37 days remaining</a:t>
             </a:r>
           </a:p>
         </p:txBody>
@@ -4938,7 +4938,7 @@
               </a:defRPr>
             </a:pPr>
             <a:r>
-              <a:t>Generated May 23, 2026</a:t>
+              <a:t>Generated May 24, 2026</a:t>
             </a:r>
           </a:p>
         </p:txBody>
@@ -5019,7 +5019,7 @@
               </a:defRPr>
             </a:pPr>
             <a:r>
-              <a:t>$19.8M</a:t>
+              <a:t>$19.7M</a:t>
             </a:r>
           </a:p>
         </p:txBody>
@@ -5055,7 +5055,7 @@
               </a:defRPr>
             </a:pPr>
             <a:r>
-              <a:t>Team GWP Q2 YTD  |  Proj. $34.0M</a:t>
+              <a:t>Team GWP Q2 YTD  |  Proj. $33.2M</a:t>
             </a:r>
           </a:p>
         </p:txBody>
@@ -5134,7 +5134,7 @@
               </a:defRPr>
             </a:pPr>
             <a:r>
-              <a:t>Pacing 184% of Q1 Final</a:t>
+              <a:t>Pacing 180% of Q1 Final</a:t>
             </a:r>
           </a:p>
         </p:txBody>
@@ -5411,7 +5411,7 @@
               </a:defRPr>
             </a:pPr>
             <a:r>
-              <a:t>30,471</a:t>
+              <a:t>30,528</a:t>
             </a:r>
           </a:p>
         </p:txBody>
@@ -5526,7 +5526,7 @@
               </a:defRPr>
             </a:pPr>
             <a:r>
-              <a:t>Pacing 114% of Q1 Final</a:t>
+              <a:t>Pacing 112% of Q1 Final</a:t>
             </a:r>
           </a:p>
         </p:txBody>
@@ -5758,7 +5758,7 @@
               </a:defRPr>
             </a:pPr>
             <a:r>
-              <a:t>▲ $4.0M vs Apr pace</a:t>
+              <a:t>▲ $3.3M vs Apr pace</a:t>
             </a:r>
           </a:p>
         </p:txBody>
@@ -5830,7 +5830,7 @@
               </a:defRPr>
             </a:pPr>
             <a:r>
-              <a:t>▲ 12906 vs Apr (17565)</a:t>
+              <a:t>▲ 12967 vs Apr (17561)</a:t>
             </a:r>
           </a:p>
         </p:txBody>
@@ -6071,7 +6071,7 @@
               </a:defRPr>
             </a:pPr>
             <a:r>
-              <a:t>$27.2M</a:t>
+              <a:t>$27.3M</a:t>
             </a:r>
           </a:p>
         </p:txBody>
@@ -6107,7 +6107,7 @@
               </a:defRPr>
             </a:pPr>
             <a:r>
-              <a:t>New Business (70%)</a:t>
+              <a:t>New Business (71%)</a:t>
             </a:r>
           </a:p>
         </p:txBody>
@@ -6600,7 +6600,7 @@
               </a:defRPr>
             </a:pPr>
             <a:r>
-              <a:t>45,795</a:t>
+              <a:t>45,794</a:t>
             </a:r>
           </a:p>
         </p:txBody>
@@ -6787,7 +6787,7 @@
               </a:defRPr>
             </a:pPr>
             <a:r>
-              <a:t>MTD (May):  $10.14M written  ·  $13.67M pace  ·  23/31 days elapsed</a:t>
+              <a:t>MTD (May):  $10.06M written  ·  $12.99M pace  ·  24/31 days elapsed</a:t>
             </a:r>
           </a:p>
         </p:txBody>
@@ -6952,7 +6952,7 @@
               </a:defRPr>
             </a:pPr>
             <a:r>
-              <a:t>Largest fleet policies written Apr 1–May 23  ·  Ranked by premium  ·  Fleet = 4+ power units</a:t>
+              <a:t>Largest fleet policies written Apr 1–May 24  ·  Ranked by premium  ·  Fleet = 4+ power units</a:t>
             </a:r>
           </a:p>
         </p:txBody>
@@ -6988,7 +6988,7 @@
               </a:defRPr>
             </a:pPr>
             <a:r>
-              <a:t>Generated May 23, 2026</a:t>
+              <a:t>Generated May 24, 2026</a:t>
             </a:r>
           </a:p>
         </p:txBody>
@@ -11750,7 +11750,7 @@
               </a:defRPr>
             </a:pPr>
             <a:r>
-              <a:t>Q2 Fleet Total: 217 fleet binds  ·  $20.0M bound premium</a:t>
+              <a:t>Q2 Fleet Total: 216 fleet binds  ·  $19.9M bound premium</a:t>
             </a:r>
           </a:p>
         </p:txBody>
@@ -11891,7 +11891,7 @@
               </a:defRPr>
             </a:pPr>
             <a:r>
-              <a:t>Ranked by bound GWP written  ·  Mint-shaded row = new vs last week’s deck  ·  Apr 1–May 23  ·  Individual producers</a:t>
+              <a:t>Ranked by bound GWP written  ·  Mint-shaded row = new vs last week’s deck  ·  Apr 1–May 24  ·  Individual producers</a:t>
             </a:r>
           </a:p>
         </p:txBody>
@@ -11927,7 +11927,7 @@
               </a:defRPr>
             </a:pPr>
             <a:r>
-              <a:t>Generated May 23, 2026</a:t>
+              <a:t>Generated May 24, 2026</a:t>
             </a:r>
           </a:p>
         </p:txBody>
@@ -12301,7 +12301,7 @@
               </a:defRPr>
             </a:pPr>
             <a:r>
-              <a:t>$4.1M</a:t>
+              <a:t>$4.2M</a:t>
             </a:r>
           </a:p>
         </p:txBody>
@@ -13423,7 +13423,7 @@
               </a:defRPr>
             </a:pPr>
             <a:r>
-              <a:t>$1.2M</a:t>
+              <a:t>$1.3M</a:t>
             </a:r>
           </a:p>
         </p:txBody>
@@ -15854,7 +15854,7 @@
               </a:defRPr>
             </a:pPr>
             <a:r>
-              <a:t>$503K</a:t>
+              <a:t>$507K</a:t>
             </a:r>
           </a:p>
         </p:txBody>
@@ -17557,6 +17557,193 @@
             <a:avLst/>
           </a:prstGeom>
           <a:solidFill>
+            <a:srgbClr val="FFFFFF"/>
+          </a:solidFill>
+          <a:ln>
+            <a:noFill/>
+          </a:ln>
+        </p:spPr>
+        <p:style>
+          <a:lnRef idx="1">
+            <a:schemeClr val="accent1"/>
+          </a:lnRef>
+          <a:fillRef idx="3">
+            <a:schemeClr val="accent1"/>
+          </a:fillRef>
+          <a:effectRef idx="2">
+            <a:schemeClr val="accent1"/>
+          </a:effectRef>
+          <a:fontRef idx="minor">
+            <a:schemeClr val="lt1"/>
+          </a:fontRef>
+        </p:style>
+        <p:txBody>
+          <a:bodyPr rtlCol="0" anchor="ctr"/>
+          <a:lstStyle/>
+          <a:p>
+            <a:pPr algn="ctr"/>
+          </a:p>
+        </p:txBody>
+      </p:sp>
+      <p:sp>
+        <p:nvSpPr>
+          <p:cNvPr id="157" name="TextBox 156"/>
+          <p:cNvSpPr txBox="1"/>
+          <p:nvPr/>
+        </p:nvSpPr>
+        <p:spPr>
+          <a:xfrm>
+            <a:off x="6254496" y="3145536"/>
+            <a:ext cx="411480" cy="237744"/>
+          </a:xfrm>
+          <a:prstGeom prst="rect">
+            <a:avLst/>
+          </a:prstGeom>
+          <a:noFill/>
+        </p:spPr>
+        <p:txBody>
+          <a:bodyPr wrap="none">
+            <a:spAutoFit/>
+          </a:bodyPr>
+          <a:lstStyle/>
+          <a:p>
+            <a:pPr algn="ctr">
+              <a:defRPr sz="950" b="1">
+                <a:solidFill>
+                  <a:srgbClr val="6B7280"/>
+                </a:solidFill>
+                <a:latin typeface="Calibri"/>
+              </a:defRPr>
+            </a:pPr>
+            <a:r>
+              <a:t>29</a:t>
+            </a:r>
+          </a:p>
+        </p:txBody>
+      </p:sp>
+      <p:sp>
+        <p:nvSpPr>
+          <p:cNvPr id="158" name="TextBox 157"/>
+          <p:cNvSpPr txBox="1"/>
+          <p:nvPr/>
+        </p:nvSpPr>
+        <p:spPr>
+          <a:xfrm>
+            <a:off x="6665976" y="3145536"/>
+            <a:ext cx="1920240" cy="237744"/>
+          </a:xfrm>
+          <a:prstGeom prst="rect">
+            <a:avLst/>
+          </a:prstGeom>
+          <a:noFill/>
+        </p:spPr>
+        <p:txBody>
+          <a:bodyPr wrap="none">
+            <a:spAutoFit/>
+          </a:bodyPr>
+          <a:lstStyle/>
+          <a:p>
+            <a:pPr algn="l">
+              <a:defRPr sz="950" b="1">
+                <a:solidFill>
+                  <a:srgbClr val="111827"/>
+                </a:solidFill>
+                <a:latin typeface="Calibri"/>
+              </a:defRPr>
+            </a:pPr>
+            <a:r>
+              <a:t>Daliborka Savovic</a:t>
+            </a:r>
+          </a:p>
+        </p:txBody>
+      </p:sp>
+      <p:sp>
+        <p:nvSpPr>
+          <p:cNvPr id="159" name="TextBox 158"/>
+          <p:cNvSpPr txBox="1"/>
+          <p:nvPr/>
+        </p:nvSpPr>
+        <p:spPr>
+          <a:xfrm>
+            <a:off x="8586216" y="3145536"/>
+            <a:ext cx="2459736" cy="237744"/>
+          </a:xfrm>
+          <a:prstGeom prst="rect">
+            <a:avLst/>
+          </a:prstGeom>
+          <a:noFill/>
+        </p:spPr>
+        <p:txBody>
+          <a:bodyPr wrap="none">
+            <a:spAutoFit/>
+          </a:bodyPr>
+          <a:lstStyle/>
+          <a:p>
+            <a:pPr algn="l">
+              <a:defRPr sz="950" b="0">
+                <a:solidFill>
+                  <a:srgbClr val="6B7280"/>
+                </a:solidFill>
+                <a:latin typeface="Calibri"/>
+              </a:defRPr>
+            </a:pPr>
+            <a:r>
+              <a:t>Alpha Trucking Insurance Agency In…</a:t>
+            </a:r>
+          </a:p>
+        </p:txBody>
+      </p:sp>
+      <p:sp>
+        <p:nvSpPr>
+          <p:cNvPr id="160" name="TextBox 159"/>
+          <p:cNvSpPr txBox="1"/>
+          <p:nvPr/>
+        </p:nvSpPr>
+        <p:spPr>
+          <a:xfrm>
+            <a:off x="11045952" y="3145536"/>
+            <a:ext cx="914400" cy="237744"/>
+          </a:xfrm>
+          <a:prstGeom prst="rect">
+            <a:avLst/>
+          </a:prstGeom>
+          <a:noFill/>
+        </p:spPr>
+        <p:txBody>
+          <a:bodyPr wrap="none">
+            <a:spAutoFit/>
+          </a:bodyPr>
+          <a:lstStyle/>
+          <a:p>
+            <a:pPr algn="ctr">
+              <a:defRPr sz="950" b="1">
+                <a:solidFill>
+                  <a:srgbClr val="111827"/>
+                </a:solidFill>
+                <a:latin typeface="Calibri"/>
+              </a:defRPr>
+            </a:pPr>
+            <a:r>
+              <a:t>$396K</a:t>
+            </a:r>
+          </a:p>
+        </p:txBody>
+      </p:sp>
+      <p:sp>
+        <p:nvSpPr>
+          <p:cNvPr id="161" name="Rectangle 160"/>
+          <p:cNvSpPr/>
+          <p:nvPr/>
+        </p:nvSpPr>
+        <p:spPr>
+          <a:xfrm>
+            <a:off x="6254496" y="3383280"/>
+            <a:ext cx="5705856" cy="256032"/>
+          </a:xfrm>
+          <a:prstGeom prst="rect">
+            <a:avLst/>
+          </a:prstGeom>
+          <a:solidFill>
             <a:srgbClr val="D1FAE5"/>
           </a:solidFill>
           <a:ln>
@@ -17587,13 +17774,13 @@
       </p:sp>
       <p:sp>
         <p:nvSpPr>
-          <p:cNvPr id="157" name="TextBox 156"/>
-          <p:cNvSpPr txBox="1"/>
-          <p:nvPr/>
-        </p:nvSpPr>
-        <p:spPr>
-          <a:xfrm>
-            <a:off x="6254496" y="3145536"/>
+          <p:cNvPr id="162" name="TextBox 161"/>
+          <p:cNvSpPr txBox="1"/>
+          <p:nvPr/>
+        </p:nvSpPr>
+        <p:spPr>
+          <a:xfrm>
+            <a:off x="6254496" y="3401568"/>
             <a:ext cx="411480" cy="237744"/>
           </a:xfrm>
           <a:prstGeom prst="rect">
@@ -17616,20 +17803,20 @@
               </a:defRPr>
             </a:pPr>
             <a:r>
-              <a:t>29</a:t>
-            </a:r>
-          </a:p>
-        </p:txBody>
-      </p:sp>
-      <p:sp>
-        <p:nvSpPr>
-          <p:cNvPr id="158" name="TextBox 157"/>
-          <p:cNvSpPr txBox="1"/>
-          <p:nvPr/>
-        </p:nvSpPr>
-        <p:spPr>
-          <a:xfrm>
-            <a:off x="6665976" y="3145536"/>
+              <a:t>30</a:t>
+            </a:r>
+          </a:p>
+        </p:txBody>
+      </p:sp>
+      <p:sp>
+        <p:nvSpPr>
+          <p:cNvPr id="163" name="TextBox 162"/>
+          <p:cNvSpPr txBox="1"/>
+          <p:nvPr/>
+        </p:nvSpPr>
+        <p:spPr>
+          <a:xfrm>
+            <a:off x="6665976" y="3401568"/>
             <a:ext cx="1920240" cy="237744"/>
           </a:xfrm>
           <a:prstGeom prst="rect">
@@ -17659,13 +17846,13 @@
       </p:sp>
       <p:sp>
         <p:nvSpPr>
-          <p:cNvPr id="159" name="TextBox 158"/>
-          <p:cNvSpPr txBox="1"/>
-          <p:nvPr/>
-        </p:nvSpPr>
-        <p:spPr>
-          <a:xfrm>
-            <a:off x="8586216" y="3145536"/>
+          <p:cNvPr id="164" name="TextBox 163"/>
+          <p:cNvSpPr txBox="1"/>
+          <p:nvPr/>
+        </p:nvSpPr>
+        <p:spPr>
+          <a:xfrm>
+            <a:off x="8586216" y="3401568"/>
             <a:ext cx="2459736" cy="237744"/>
           </a:xfrm>
           <a:prstGeom prst="rect">
@@ -17695,193 +17882,6 @@
       </p:sp>
       <p:sp>
         <p:nvSpPr>
-          <p:cNvPr id="160" name="TextBox 159"/>
-          <p:cNvSpPr txBox="1"/>
-          <p:nvPr/>
-        </p:nvSpPr>
-        <p:spPr>
-          <a:xfrm>
-            <a:off x="11045952" y="3145536"/>
-            <a:ext cx="914400" cy="237744"/>
-          </a:xfrm>
-          <a:prstGeom prst="rect">
-            <a:avLst/>
-          </a:prstGeom>
-          <a:noFill/>
-        </p:spPr>
-        <p:txBody>
-          <a:bodyPr wrap="none">
-            <a:spAutoFit/>
-          </a:bodyPr>
-          <a:lstStyle/>
-          <a:p>
-            <a:pPr algn="ctr">
-              <a:defRPr sz="950" b="1">
-                <a:solidFill>
-                  <a:srgbClr val="111827"/>
-                </a:solidFill>
-                <a:latin typeface="Calibri"/>
-              </a:defRPr>
-            </a:pPr>
-            <a:r>
-              <a:t>$388K</a:t>
-            </a:r>
-          </a:p>
-        </p:txBody>
-      </p:sp>
-      <p:sp>
-        <p:nvSpPr>
-          <p:cNvPr id="161" name="Rectangle 160"/>
-          <p:cNvSpPr/>
-          <p:nvPr/>
-        </p:nvSpPr>
-        <p:spPr>
-          <a:xfrm>
-            <a:off x="6254496" y="3383280"/>
-            <a:ext cx="5705856" cy="256032"/>
-          </a:xfrm>
-          <a:prstGeom prst="rect">
-            <a:avLst/>
-          </a:prstGeom>
-          <a:solidFill>
-            <a:srgbClr val="F9FAFB"/>
-          </a:solidFill>
-          <a:ln>
-            <a:noFill/>
-          </a:ln>
-        </p:spPr>
-        <p:style>
-          <a:lnRef idx="1">
-            <a:schemeClr val="accent1"/>
-          </a:lnRef>
-          <a:fillRef idx="3">
-            <a:schemeClr val="accent1"/>
-          </a:fillRef>
-          <a:effectRef idx="2">
-            <a:schemeClr val="accent1"/>
-          </a:effectRef>
-          <a:fontRef idx="minor">
-            <a:schemeClr val="lt1"/>
-          </a:fontRef>
-        </p:style>
-        <p:txBody>
-          <a:bodyPr rtlCol="0" anchor="ctr"/>
-          <a:lstStyle/>
-          <a:p>
-            <a:pPr algn="ctr"/>
-          </a:p>
-        </p:txBody>
-      </p:sp>
-      <p:sp>
-        <p:nvSpPr>
-          <p:cNvPr id="162" name="TextBox 161"/>
-          <p:cNvSpPr txBox="1"/>
-          <p:nvPr/>
-        </p:nvSpPr>
-        <p:spPr>
-          <a:xfrm>
-            <a:off x="6254496" y="3401568"/>
-            <a:ext cx="411480" cy="237744"/>
-          </a:xfrm>
-          <a:prstGeom prst="rect">
-            <a:avLst/>
-          </a:prstGeom>
-          <a:noFill/>
-        </p:spPr>
-        <p:txBody>
-          <a:bodyPr wrap="none">
-            <a:spAutoFit/>
-          </a:bodyPr>
-          <a:lstStyle/>
-          <a:p>
-            <a:pPr algn="ctr">
-              <a:defRPr sz="950" b="1">
-                <a:solidFill>
-                  <a:srgbClr val="6B7280"/>
-                </a:solidFill>
-                <a:latin typeface="Calibri"/>
-              </a:defRPr>
-            </a:pPr>
-            <a:r>
-              <a:t>30</a:t>
-            </a:r>
-          </a:p>
-        </p:txBody>
-      </p:sp>
-      <p:sp>
-        <p:nvSpPr>
-          <p:cNvPr id="163" name="TextBox 162"/>
-          <p:cNvSpPr txBox="1"/>
-          <p:nvPr/>
-        </p:nvSpPr>
-        <p:spPr>
-          <a:xfrm>
-            <a:off x="6665976" y="3401568"/>
-            <a:ext cx="1920240" cy="237744"/>
-          </a:xfrm>
-          <a:prstGeom prst="rect">
-            <a:avLst/>
-          </a:prstGeom>
-          <a:noFill/>
-        </p:spPr>
-        <p:txBody>
-          <a:bodyPr wrap="none">
-            <a:spAutoFit/>
-          </a:bodyPr>
-          <a:lstStyle/>
-          <a:p>
-            <a:pPr algn="l">
-              <a:defRPr sz="950" b="1">
-                <a:solidFill>
-                  <a:srgbClr val="111827"/>
-                </a:solidFill>
-                <a:latin typeface="Calibri"/>
-              </a:defRPr>
-            </a:pPr>
-            <a:r>
-              <a:t>Daliborka Savovic</a:t>
-            </a:r>
-          </a:p>
-        </p:txBody>
-      </p:sp>
-      <p:sp>
-        <p:nvSpPr>
-          <p:cNvPr id="164" name="TextBox 163"/>
-          <p:cNvSpPr txBox="1"/>
-          <p:nvPr/>
-        </p:nvSpPr>
-        <p:spPr>
-          <a:xfrm>
-            <a:off x="8586216" y="3401568"/>
-            <a:ext cx="2459736" cy="237744"/>
-          </a:xfrm>
-          <a:prstGeom prst="rect">
-            <a:avLst/>
-          </a:prstGeom>
-          <a:noFill/>
-        </p:spPr>
-        <p:txBody>
-          <a:bodyPr wrap="none">
-            <a:spAutoFit/>
-          </a:bodyPr>
-          <a:lstStyle/>
-          <a:p>
-            <a:pPr algn="l">
-              <a:defRPr sz="950" b="0">
-                <a:solidFill>
-                  <a:srgbClr val="6B7280"/>
-                </a:solidFill>
-                <a:latin typeface="Calibri"/>
-              </a:defRPr>
-            </a:pPr>
-            <a:r>
-              <a:t>Alpha Trucking Insurance Agency In…</a:t>
-            </a:r>
-          </a:p>
-        </p:txBody>
-      </p:sp>
-      <p:sp>
-        <p:nvSpPr>
           <p:cNvPr id="165" name="TextBox 164"/>
           <p:cNvSpPr txBox="1"/>
           <p:nvPr/>
@@ -17911,7 +17911,7 @@
               </a:defRPr>
             </a:pPr>
             <a:r>
-              <a:t>$380K</a:t>
+              <a:t>$388K</a:t>
             </a:r>
           </a:p>
         </p:txBody>
@@ -19922,7 +19922,7 @@
               </a:defRPr>
             </a:pPr>
             <a:r>
-              <a:t>Q2 2026 YTD (Apr 1–May 23)  |  Green = on target  |  Amber = at risk  |  Red = behind  |  Goal: ≥40 acts/wk  |  Ranked by composite OKR score</a:t>
+              <a:t>Q2 2026 YTD (Apr 1–May 24)  |  Green = on target  |  Amber = at risk  |  Red = behind  |  Goal: ≥40 acts/wk  |  Ranked by composite OKR score</a:t>
             </a:r>
           </a:p>
         </p:txBody>
@@ -19958,7 +19958,7 @@
               </a:defRPr>
             </a:pPr>
             <a:r>
-              <a:t>Generated May 23, 2026</a:t>
+              <a:t>Generated May 24, 2026</a:t>
             </a:r>
           </a:p>
         </p:txBody>
@@ -20123,7 +20123,7 @@
               </a:defRPr>
             </a:pPr>
             <a:r>
-              <a:t>Q2 2026 YTD (Apr 1–May 23)  |  Green = on target  |  Amber = at risk  |  Red = behind  |  Goal: ≥50 acts/wk  |  Ranked by composite OKR score</a:t>
+              <a:t>Q2 2026 YTD (Apr 1–May 24)  |  Green = on target  |  Amber = at risk  |  Red = behind  |  Goal: ≥50 acts/wk  |  Ranked by composite OKR score</a:t>
             </a:r>
           </a:p>
         </p:txBody>
@@ -20159,7 +20159,7 @@
               </a:defRPr>
             </a:pPr>
             <a:r>
-              <a:t>Generated May 23, 2026</a:t>
+              <a:t>Generated May 24, 2026</a:t>
             </a:r>
           </a:p>
         </p:txBody>
@@ -20324,7 +20324,7 @@
               </a:defRPr>
             </a:pPr>
             <a:r>
-              <a:t>Q2 YTD  |  Apr 1–May 23  |  BDMs Only  |  Goal: 40 acts/wk  |  Emails excluded</a:t>
+              <a:t>Q2 YTD  |  Apr 1–May 24  |  BDMs Only  |  Goal: 40 acts/wk  |  Emails excluded</a:t>
             </a:r>
           </a:p>
         </p:txBody>
@@ -20360,7 +20360,7 @@
               </a:defRPr>
             </a:pPr>
             <a:r>
-              <a:t>Generated May 23, 2026</a:t>
+              <a:t>Generated May 24, 2026</a:t>
             </a:r>
           </a:p>
         </p:txBody>
@@ -20691,7 +20691,7 @@
               </a:defRPr>
             </a:pPr>
             <a:r>
-              <a:t>May 18-23</a:t>
+              <a:t>May 18-24</a:t>
             </a:r>
           </a:p>
         </p:txBody>
@@ -26935,7 +26935,7 @@
               </a:defRPr>
             </a:pPr>
             <a:r>
-              <a:t>Q2 YTD  |  Apr 1–May 23  |  BDAs Only  |  Goal: 50 acts/wk  |  Emails excluded</a:t>
+              <a:t>Q2 YTD  |  Apr 1–May 24  |  BDAs Only  |  Goal: 50 acts/wk  |  Emails excluded</a:t>
             </a:r>
           </a:p>
         </p:txBody>
@@ -26971,7 +26971,7 @@
               </a:defRPr>
             </a:pPr>
             <a:r>
-              <a:t>Generated May 23, 2026</a:t>
+              <a:t>Generated May 24, 2026</a:t>
             </a:r>
           </a:p>
         </p:txBody>
@@ -27302,7 +27302,7 @@
               </a:defRPr>
             </a:pPr>
             <a:r>
-              <a:t>May 18-23</a:t>
+              <a:t>May 18-24</a:t>
             </a:r>
           </a:p>
         </p:txBody>
@@ -32367,7 +32367,7 @@
               </a:defRPr>
             </a:pPr>
             <a:r>
-              <a:t>Generated May 23, 2026</a:t>
+              <a:t>Generated May 24, 2026</a:t>
             </a:r>
           </a:p>
         </p:txBody>
@@ -33058,7 +33058,7 @@
               </a:defRPr>
             </a:pPr>
             <a:r>
-              <a:t>6932</a:t>
+              <a:t>6943</a:t>
             </a:r>
           </a:p>
         </p:txBody>
@@ -33130,7 +33130,7 @@
               </a:defRPr>
             </a:pPr>
             <a:r>
-              <a:t>$16.5M</a:t>
+              <a:t>$16.4M</a:t>
             </a:r>
           </a:p>
         </p:txBody>
@@ -33497,7 +33497,7 @@
               </a:defRPr>
             </a:pPr>
             <a:r>
-              <a:t>3336</a:t>
+              <a:t>3341</a:t>
             </a:r>
           </a:p>
         </p:txBody>
@@ -33533,7 +33533,7 @@
               </a:defRPr>
             </a:pPr>
             <a:r>
-              <a:t>335</a:t>
+              <a:t>331</a:t>
             </a:r>
           </a:p>
         </p:txBody>
@@ -33569,7 +33569,7 @@
               </a:defRPr>
             </a:pPr>
             <a:r>
-              <a:t>$9.3M</a:t>
+              <a:t>$9.2M</a:t>
             </a:r>
           </a:p>
         </p:txBody>
@@ -33893,7 +33893,7 @@
               </a:defRPr>
             </a:pPr>
             <a:r>
-              <a:t>5294</a:t>
+              <a:t>5304</a:t>
             </a:r>
           </a:p>
         </p:txBody>
@@ -34332,7 +34332,7 @@
               </a:defRPr>
             </a:pPr>
             <a:r>
-              <a:t>3227</a:t>
+              <a:t>3236</a:t>
             </a:r>
           </a:p>
         </p:txBody>
@@ -34368,7 +34368,7 @@
               </a:defRPr>
             </a:pPr>
             <a:r>
-              <a:t>259</a:t>
+              <a:t>257</a:t>
             </a:r>
           </a:p>
         </p:txBody>
@@ -34476,7 +34476,7 @@
               </a:defRPr>
             </a:pPr>
             <a:r>
-              <a:t>$1.6M</a:t>
+              <a:t>$1.7M</a:t>
             </a:r>
           </a:p>
         </p:txBody>
@@ -34728,7 +34728,7 @@
               </a:defRPr>
             </a:pPr>
             <a:r>
-              <a:t>1802</a:t>
+              <a:t>1809</a:t>
             </a:r>
           </a:p>
         </p:txBody>
@@ -34764,7 +34764,7 @@
               </a:defRPr>
             </a:pPr>
             <a:r>
-              <a:t>126</a:t>
+              <a:t>127</a:t>
             </a:r>
           </a:p>
         </p:txBody>
@@ -35246,7 +35246,7 @@
               </a:defRPr>
             </a:pPr>
             <a:r>
-              <a:t>3932</a:t>
+              <a:t>3937</a:t>
             </a:r>
           </a:p>
         </p:txBody>
@@ -35642,7 +35642,7 @@
               </a:defRPr>
             </a:pPr>
             <a:r>
-              <a:t>2675</a:t>
+              <a:t>2682</a:t>
             </a:r>
           </a:p>
         </p:txBody>
@@ -35786,7 +35786,7 @@
               </a:defRPr>
             </a:pPr>
             <a:r>
-              <a:t>$224K</a:t>
+              <a:t>$246K</a:t>
             </a:r>
           </a:p>
         </p:txBody>
@@ -36081,7 +36081,7 @@
               </a:defRPr>
             </a:pPr>
             <a:r>
-              <a:t>1560</a:t>
+              <a:t>1561</a:t>
             </a:r>
           </a:p>
         </p:txBody>
@@ -36477,7 +36477,7 @@
               </a:defRPr>
             </a:pPr>
             <a:r>
-              <a:t>909</a:t>
+              <a:t>910</a:t>
             </a:r>
           </a:p>
         </p:txBody>
@@ -36513,7 +36513,7 @@
               </a:defRPr>
             </a:pPr>
             <a:r>
-              <a:t>52</a:t>
+              <a:t>51</a:t>
             </a:r>
           </a:p>
         </p:txBody>
@@ -37434,7 +37434,7 @@
               </a:defRPr>
             </a:pPr>
             <a:r>
-              <a:t>7404</a:t>
+              <a:t>7416</a:t>
             </a:r>
           </a:p>
         </p:txBody>
@@ -37470,7 +37470,7 @@
               </a:defRPr>
             </a:pPr>
             <a:r>
-              <a:t>288</a:t>
+              <a:t>287</a:t>
             </a:r>
           </a:p>
         </p:txBody>
@@ -38193,7 +38193,7 @@
               </a:defRPr>
             </a:pPr>
             <a:r>
-              <a:t>Retail-vertical agencies in each rep's HubSpot portfolio with zero 2026 submissions  |  Refreshed 2026-05-23</a:t>
+              <a:t>Retail-vertical agencies in each rep's HubSpot portfolio with zero 2026 submissions  |  Refreshed 2026-05-24</a:t>
             </a:r>
           </a:p>
         </p:txBody>
@@ -38229,7 +38229,7 @@
               </a:defRPr>
             </a:pPr>
             <a:r>
-              <a:t>Generated May 23, 2026</a:t>
+              <a:t>Generated May 24, 2026</a:t>
             </a:r>
           </a:p>
         </p:txBody>
@@ -40770,7 +40770,7 @@
               </a:defRPr>
             </a:pPr>
             <a:r>
-              <a:t>Generated May 23, 2026</a:t>
+              <a:t>Generated May 24, 2026</a:t>
             </a:r>
           </a:p>
         </p:txBody>
@@ -40935,7 +40935,7 @@
               </a:defRPr>
             </a:pPr>
             <a:r>
-              <a:t>Ranked by Q2 GWP (left) and Q2 Submissions (right)  ·  Mint-shaded row = new vs last week’s deck  ·  Apr 1–May 23</a:t>
+              <a:t>Ranked by Q2 GWP (left) and Q2 Submissions (right)  ·  Mint-shaded row = new vs last week’s deck  ·  Apr 1–May 24</a:t>
             </a:r>
           </a:p>
         </p:txBody>
@@ -40971,7 +40971,7 @@
               </a:defRPr>
             </a:pPr>
             <a:r>
-              <a:t>Generated May 23, 2026</a:t>
+              <a:t>Generated May 24, 2026</a:t>
             </a:r>
           </a:p>
         </p:txBody>
@@ -41424,7 +41424,7 @@
               </a:defRPr>
             </a:pPr>
             <a:r>
-              <a:t>$3.1M</a:t>
+              <a:t>$3.0M</a:t>
             </a:r>
           </a:p>
         </p:txBody>
@@ -41575,7 +41575,7 @@
               </a:defRPr>
             </a:pPr>
             <a:r>
-              <a:t>Jagdeep Singh Insurance Agency, Inc</a:t>
+              <a:t>Reliance Partners, LLC</a:t>
             </a:r>
           </a:p>
         </p:txBody>
@@ -41726,7 +41726,7 @@
               </a:defRPr>
             </a:pPr>
             <a:r>
-              <a:t>Derek J.</a:t>
+              <a:t>Christopher H.</a:t>
             </a:r>
           </a:p>
         </p:txBody>
@@ -41762,7 +41762,7 @@
               </a:defRPr>
             </a:pPr>
             <a:r>
-              <a:t>Reliance Partners, LLC</a:t>
+              <a:t>Commercial Trucking Insurance Agency LLC</a:t>
             </a:r>
           </a:p>
         </p:txBody>
@@ -41913,7 +41913,7 @@
               </a:defRPr>
             </a:pPr>
             <a:r>
-              <a:t>Christopher H.</a:t>
+              <a:t>Derek J.</a:t>
             </a:r>
           </a:p>
         </p:txBody>
@@ -41949,7 +41949,7 @@
               </a:defRPr>
             </a:pPr>
             <a:r>
-              <a:t>Commercial Trucking Insurance Agency LLC</a:t>
+              <a:t>Jagdeep Singh Insurance Agency, Inc</a:t>
             </a:r>
           </a:p>
         </p:txBody>
@@ -41985,7 +41985,7 @@
               </a:defRPr>
             </a:pPr>
             <a:r>
-              <a:t>$1.9M</a:t>
+              <a:t>$1.8M</a:t>
             </a:r>
           </a:p>
         </p:txBody>
@@ -42172,7 +42172,7 @@
               </a:defRPr>
             </a:pPr>
             <a:r>
-              <a:t>$1.7M</a:t>
+              <a:t>$1.6M</a:t>
             </a:r>
           </a:p>
         </p:txBody>
@@ -42848,7 +42848,7 @@
               </a:defRPr>
             </a:pPr>
             <a:r>
-              <a:t>Derrick L.</a:t>
+              <a:t>Derek J.</a:t>
             </a:r>
           </a:p>
         </p:txBody>
@@ -42884,7 +42884,7 @@
               </a:defRPr>
             </a:pPr>
             <a:r>
-              <a:t>AMC Agents LLC</a:t>
+              <a:t>CASCADE INSURANCE SERVICES INC DBA: CASC…</a:t>
             </a:r>
           </a:p>
         </p:txBody>
@@ -43035,7 +43035,7 @@
               </a:defRPr>
             </a:pPr>
             <a:r>
-              <a:t>Derek J.</a:t>
+              <a:t>Derrick L.</a:t>
             </a:r>
           </a:p>
         </p:txBody>
@@ -43071,7 +43071,7 @@
               </a:defRPr>
             </a:pPr>
             <a:r>
-              <a:t>CASCADE INSURANCE SERVICES INC DBA: CASC…</a:t>
+              <a:t>AMC Agents LLC</a:t>
             </a:r>
           </a:p>
         </p:txBody>
@@ -43668,7 +43668,7 @@
               </a:defRPr>
             </a:pPr>
             <a:r>
-              <a:t>$980K</a:t>
+              <a:t>$981K</a:t>
             </a:r>
           </a:p>
         </p:txBody>
@@ -45430,7 +45430,7 @@
               </a:defRPr>
             </a:pPr>
             <a:r>
-              <a:t>2191</a:t>
+              <a:t>2193</a:t>
             </a:r>
           </a:p>
         </p:txBody>
@@ -45617,7 +45617,7 @@
               </a:defRPr>
             </a:pPr>
             <a:r>
-              <a:t>2032</a:t>
+              <a:t>2039</a:t>
             </a:r>
           </a:p>
         </p:txBody>
@@ -45804,7 +45804,7 @@
               </a:defRPr>
             </a:pPr>
             <a:r>
-              <a:t>1542</a:t>
+              <a:t>1543</a:t>
             </a:r>
           </a:p>
         </p:txBody>
@@ -46365,7 +46365,7 @@
               </a:defRPr>
             </a:pPr>
             <a:r>
-              <a:t>1004</a:t>
+              <a:t>1008</a:t>
             </a:r>
           </a:p>
         </p:txBody>
@@ -46552,7 +46552,7 @@
               </a:defRPr>
             </a:pPr>
             <a:r>
-              <a:t>972</a:t>
+              <a:t>974</a:t>
             </a:r>
           </a:p>
         </p:txBody>
@@ -46739,7 +46739,7 @@
               </a:defRPr>
             </a:pPr>
             <a:r>
-              <a:t>903</a:t>
+              <a:t>909</a:t>
             </a:r>
           </a:p>
         </p:txBody>
@@ -47487,7 +47487,7 @@
               </a:defRPr>
             </a:pPr>
             <a:r>
-              <a:t>493</a:t>
+              <a:t>496</a:t>
             </a:r>
           </a:p>
         </p:txBody>
@@ -47674,7 +47674,7 @@
               </a:defRPr>
             </a:pPr>
             <a:r>
-              <a:t>447</a:t>
+              <a:t>450</a:t>
             </a:r>
           </a:p>
         </p:txBody>

</xml_diff>

<commit_message>
Daily rebuild Tue 05/26/2026  9:06:48.00
</commit_message>
<xml_diff>
--- a/generated/Sales Dashboards/BD Rep Scoreboard.pptx
+++ b/generated/Sales Dashboards/BD Rep Scoreboard.pptx
@@ -1661,7 +1661,7 @@
           </a:p>
           <a:p>
             <a:r>
-              <a:t>- We are 55 days into a 91-day quarter.</a:t>
+              <a:t>- We are 56 days into a 91-day quarter.</a:t>
             </a:r>
           </a:p>
         </p:txBody>
@@ -4902,7 +4902,7 @@
               </a:defRPr>
             </a:pPr>
             <a:r>
-              <a:t>As of May 25, 2026  |  55 days into Q2  |  36 days remaining</a:t>
+              <a:t>As of May 26, 2026  |  56 days into Q2  |  35 days remaining</a:t>
             </a:r>
           </a:p>
         </p:txBody>
@@ -4938,7 +4938,7 @@
               </a:defRPr>
             </a:pPr>
             <a:r>
-              <a:t>Generated May 25, 2026</a:t>
+              <a:t>Generated May 26, 2026</a:t>
             </a:r>
           </a:p>
         </p:txBody>
@@ -5019,7 +5019,7 @@
               </a:defRPr>
             </a:pPr>
             <a:r>
-              <a:t>$19.7M</a:t>
+              <a:t>$19.6M</a:t>
             </a:r>
           </a:p>
         </p:txBody>
@@ -5055,7 +5055,7 @@
               </a:defRPr>
             </a:pPr>
             <a:r>
-              <a:t>Team GWP Q2 YTD  |  Proj. $32.5M</a:t>
+              <a:t>Team GWP Q2 YTD  |  Proj. $31.8M</a:t>
             </a:r>
           </a:p>
         </p:txBody>
@@ -5134,7 +5134,7 @@
               </a:defRPr>
             </a:pPr>
             <a:r>
-              <a:t>Pacing 176% of Q1 Final</a:t>
+              <a:t>Pacing 172% of Q1 Final</a:t>
             </a:r>
           </a:p>
         </p:txBody>
@@ -5411,7 +5411,7 @@
               </a:defRPr>
             </a:pPr>
             <a:r>
-              <a:t>30,570</a:t>
+              <a:t>30,703</a:t>
             </a:r>
           </a:p>
         </p:txBody>
@@ -5526,7 +5526,7 @@
               </a:defRPr>
             </a:pPr>
             <a:r>
-              <a:t>Pacing 110% of Q1 Final</a:t>
+              <a:t>Pacing 109% of Q1 Final</a:t>
             </a:r>
           </a:p>
         </p:txBody>
@@ -5758,7 +5758,7 @@
               </a:defRPr>
             </a:pPr>
             <a:r>
-              <a:t>▲ $2.8M vs Apr pace</a:t>
+              <a:t>▲ $2.2M vs Apr pace</a:t>
             </a:r>
           </a:p>
         </p:txBody>
@@ -5830,7 +5830,7 @@
               </a:defRPr>
             </a:pPr>
             <a:r>
-              <a:t>▲ 13010 vs Apr (17560)</a:t>
+              <a:t>▲ 13138 vs Apr (17565)</a:t>
             </a:r>
           </a:p>
         </p:txBody>
@@ -6071,7 +6071,7 @@
               </a:defRPr>
             </a:pPr>
             <a:r>
-              <a:t>$27.4M</a:t>
+              <a:t>$27.5M</a:t>
             </a:r>
           </a:p>
         </p:txBody>
@@ -6600,7 +6600,7 @@
               </a:defRPr>
             </a:pPr>
             <a:r>
-              <a:t>45,791</a:t>
+              <a:t>45,795</a:t>
             </a:r>
           </a:p>
         </p:txBody>
@@ -6787,7 +6787,7 @@
               </a:defRPr>
             </a:pPr>
             <a:r>
-              <a:t>MTD (May):  $10.03M written  ·  $12.43M pace  ·  25/31 days elapsed</a:t>
+              <a:t>MTD (May):  $9.93M written  ·  $11.84M pace  ·  26/31 days elapsed</a:t>
             </a:r>
           </a:p>
         </p:txBody>
@@ -6952,7 +6952,7 @@
               </a:defRPr>
             </a:pPr>
             <a:r>
-              <a:t>Largest fleet policies written Apr 1–May 25  ·  Ranked by premium  ·  Fleet = 4+ power units</a:t>
+              <a:t>Largest fleet policies written Apr 1–May 26  ·  Ranked by premium  ·  Fleet = 4+ power units</a:t>
             </a:r>
           </a:p>
         </p:txBody>
@@ -6988,7 +6988,7 @@
               </a:defRPr>
             </a:pPr>
             <a:r>
-              <a:t>Generated May 25, 2026</a:t>
+              <a:t>Generated May 26, 2026</a:t>
             </a:r>
           </a:p>
         </p:txBody>
@@ -11750,7 +11750,7 @@
               </a:defRPr>
             </a:pPr>
             <a:r>
-              <a:t>Q2 Fleet Total: 217 fleet binds  ·  $20.0M bound premium</a:t>
+              <a:t>Q2 Fleet Total: 221 fleet binds  ·  $20.3M bound premium</a:t>
             </a:r>
           </a:p>
         </p:txBody>
@@ -11891,7 +11891,7 @@
               </a:defRPr>
             </a:pPr>
             <a:r>
-              <a:t>Ranked by bound GWP written  ·  Mint-shaded row = new vs last week’s deck  ·  Apr 1–May 25  ·  Individual producers</a:t>
+              <a:t>Ranked by bound GWP written  ·  Mint-shaded row = new vs last week’s deck  ·  Apr 1–May 26  ·  Individual producers</a:t>
             </a:r>
           </a:p>
         </p:txBody>
@@ -11927,7 +11927,7 @@
               </a:defRPr>
             </a:pPr>
             <a:r>
-              <a:t>Generated May 25, 2026</a:t>
+              <a:t>Generated May 26, 2026</a:t>
             </a:r>
           </a:p>
         </p:txBody>
@@ -12675,7 +12675,7 @@
               </a:defRPr>
             </a:pPr>
             <a:r>
-              <a:t>$1.6M</a:t>
+              <a:t>$1.7M</a:t>
             </a:r>
           </a:p>
         </p:txBody>
@@ -15480,7 +15480,7 @@
               </a:defRPr>
             </a:pPr>
             <a:r>
-              <a:t>$524K</a:t>
+              <a:t>$544K</a:t>
             </a:r>
           </a:p>
         </p:txBody>
@@ -16415,7 +16415,7 @@
               </a:defRPr>
             </a:pPr>
             <a:r>
-              <a:t>$472K</a:t>
+              <a:t>$492K</a:t>
             </a:r>
           </a:p>
         </p:txBody>
@@ -18213,7 +18213,7 @@
               </a:defRPr>
             </a:pPr>
             <a:r>
-              <a:t>Michael Su</a:t>
+              <a:t>Ibrahim Mammo</a:t>
             </a:r>
           </a:p>
         </p:txBody>
@@ -18249,7 +18249,7 @@
               </a:defRPr>
             </a:pPr>
             <a:r>
-              <a:t>Jtc Insurance Agency, Inc.</a:t>
+              <a:t>Surefire Insurance Agency Corp.</a:t>
             </a:r>
           </a:p>
         </p:txBody>
@@ -18285,7 +18285,7 @@
               </a:defRPr>
             </a:pPr>
             <a:r>
-              <a:t>$367K</a:t>
+              <a:t>$372K</a:t>
             </a:r>
           </a:p>
         </p:txBody>
@@ -18400,7 +18400,7 @@
               </a:defRPr>
             </a:pPr>
             <a:r>
-              <a:t>Patricia Galindoparedes</a:t>
+              <a:t>Michael Su</a:t>
             </a:r>
           </a:p>
         </p:txBody>
@@ -18436,7 +18436,7 @@
               </a:defRPr>
             </a:pPr>
             <a:r>
-              <a:t>Call Patty Insurance Services</a:t>
+              <a:t>Jtc Insurance Agency, Inc.</a:t>
             </a:r>
           </a:p>
         </p:txBody>
@@ -18472,7 +18472,7 @@
               </a:defRPr>
             </a:pPr>
             <a:r>
-              <a:t>$365K</a:t>
+              <a:t>$367K</a:t>
             </a:r>
           </a:p>
         </p:txBody>
@@ -18587,7 +18587,7 @@
               </a:defRPr>
             </a:pPr>
             <a:r>
-              <a:t>Kurtis Gautz</a:t>
+              <a:t>Patricia Galindoparedes</a:t>
             </a:r>
           </a:p>
         </p:txBody>
@@ -18623,7 +18623,7 @@
               </a:defRPr>
             </a:pPr>
             <a:r>
-              <a:t>CRC Insurance Services, Inc</a:t>
+              <a:t>Call Patty Insurance Services</a:t>
             </a:r>
           </a:p>
         </p:txBody>
@@ -18659,7 +18659,7 @@
               </a:defRPr>
             </a:pPr>
             <a:r>
-              <a:t>$352K</a:t>
+              <a:t>$365K</a:t>
             </a:r>
           </a:p>
         </p:txBody>
@@ -18774,7 +18774,7 @@
               </a:defRPr>
             </a:pPr>
             <a:r>
-              <a:t>Damandeep Singh</a:t>
+              <a:t>Kurtis Gautz</a:t>
             </a:r>
           </a:p>
         </p:txBody>
@@ -18810,7 +18810,7 @@
               </a:defRPr>
             </a:pPr>
             <a:r>
-              <a:t>Mayflower Insurance Services</a:t>
+              <a:t>CRC Insurance Services, Inc</a:t>
             </a:r>
           </a:p>
         </p:txBody>
@@ -18846,7 +18846,7 @@
               </a:defRPr>
             </a:pPr>
             <a:r>
-              <a:t>$341K</a:t>
+              <a:t>$352K</a:t>
             </a:r>
           </a:p>
         </p:txBody>
@@ -18961,7 +18961,7 @@
               </a:defRPr>
             </a:pPr>
             <a:r>
-              <a:t>Omar Elmanzalawy</a:t>
+              <a:t>Damandeep Singh</a:t>
             </a:r>
           </a:p>
         </p:txBody>
@@ -18997,7 +18997,7 @@
               </a:defRPr>
             </a:pPr>
             <a:r>
-              <a:t>First Connect Insurance</a:t>
+              <a:t>Mayflower Insurance Services</a:t>
             </a:r>
           </a:p>
         </p:txBody>
@@ -19033,7 +19033,7 @@
               </a:defRPr>
             </a:pPr>
             <a:r>
-              <a:t>$339K</a:t>
+              <a:t>$341K</a:t>
             </a:r>
           </a:p>
         </p:txBody>
@@ -19047,6 +19047,193 @@
         <p:spPr>
           <a:xfrm>
             <a:off x="6254496" y="5175504"/>
+            <a:ext cx="5705856" cy="256032"/>
+          </a:xfrm>
+          <a:prstGeom prst="rect">
+            <a:avLst/>
+          </a:prstGeom>
+          <a:solidFill>
+            <a:srgbClr val="FFFFFF"/>
+          </a:solidFill>
+          <a:ln>
+            <a:noFill/>
+          </a:ln>
+        </p:spPr>
+        <p:style>
+          <a:lnRef idx="1">
+            <a:schemeClr val="accent1"/>
+          </a:lnRef>
+          <a:fillRef idx="3">
+            <a:schemeClr val="accent1"/>
+          </a:fillRef>
+          <a:effectRef idx="2">
+            <a:schemeClr val="accent1"/>
+          </a:effectRef>
+          <a:fontRef idx="minor">
+            <a:schemeClr val="lt1"/>
+          </a:fontRef>
+        </p:style>
+        <p:txBody>
+          <a:bodyPr rtlCol="0" anchor="ctr"/>
+          <a:lstStyle/>
+          <a:p>
+            <a:pPr algn="ctr"/>
+          </a:p>
+        </p:txBody>
+      </p:sp>
+      <p:sp>
+        <p:nvSpPr>
+          <p:cNvPr id="197" name="TextBox 196"/>
+          <p:cNvSpPr txBox="1"/>
+          <p:nvPr/>
+        </p:nvSpPr>
+        <p:spPr>
+          <a:xfrm>
+            <a:off x="6254496" y="5193792"/>
+            <a:ext cx="411480" cy="237744"/>
+          </a:xfrm>
+          <a:prstGeom prst="rect">
+            <a:avLst/>
+          </a:prstGeom>
+          <a:noFill/>
+        </p:spPr>
+        <p:txBody>
+          <a:bodyPr wrap="none">
+            <a:spAutoFit/>
+          </a:bodyPr>
+          <a:lstStyle/>
+          <a:p>
+            <a:pPr algn="ctr">
+              <a:defRPr sz="950" b="1">
+                <a:solidFill>
+                  <a:srgbClr val="6B7280"/>
+                </a:solidFill>
+                <a:latin typeface="Calibri"/>
+              </a:defRPr>
+            </a:pPr>
+            <a:r>
+              <a:t>37</a:t>
+            </a:r>
+          </a:p>
+        </p:txBody>
+      </p:sp>
+      <p:sp>
+        <p:nvSpPr>
+          <p:cNvPr id="198" name="TextBox 197"/>
+          <p:cNvSpPr txBox="1"/>
+          <p:nvPr/>
+        </p:nvSpPr>
+        <p:spPr>
+          <a:xfrm>
+            <a:off x="6665976" y="5193792"/>
+            <a:ext cx="1920240" cy="237744"/>
+          </a:xfrm>
+          <a:prstGeom prst="rect">
+            <a:avLst/>
+          </a:prstGeom>
+          <a:noFill/>
+        </p:spPr>
+        <p:txBody>
+          <a:bodyPr wrap="none">
+            <a:spAutoFit/>
+          </a:bodyPr>
+          <a:lstStyle/>
+          <a:p>
+            <a:pPr algn="l">
+              <a:defRPr sz="950" b="1">
+                <a:solidFill>
+                  <a:srgbClr val="111827"/>
+                </a:solidFill>
+                <a:latin typeface="Calibri"/>
+              </a:defRPr>
+            </a:pPr>
+            <a:r>
+              <a:t>Omar Elmanzalawy</a:t>
+            </a:r>
+          </a:p>
+        </p:txBody>
+      </p:sp>
+      <p:sp>
+        <p:nvSpPr>
+          <p:cNvPr id="199" name="TextBox 198"/>
+          <p:cNvSpPr txBox="1"/>
+          <p:nvPr/>
+        </p:nvSpPr>
+        <p:spPr>
+          <a:xfrm>
+            <a:off x="8586216" y="5193792"/>
+            <a:ext cx="2459736" cy="237744"/>
+          </a:xfrm>
+          <a:prstGeom prst="rect">
+            <a:avLst/>
+          </a:prstGeom>
+          <a:noFill/>
+        </p:spPr>
+        <p:txBody>
+          <a:bodyPr wrap="none">
+            <a:spAutoFit/>
+          </a:bodyPr>
+          <a:lstStyle/>
+          <a:p>
+            <a:pPr algn="l">
+              <a:defRPr sz="950" b="0">
+                <a:solidFill>
+                  <a:srgbClr val="6B7280"/>
+                </a:solidFill>
+                <a:latin typeface="Calibri"/>
+              </a:defRPr>
+            </a:pPr>
+            <a:r>
+              <a:t>First Connect Insurance</a:t>
+            </a:r>
+          </a:p>
+        </p:txBody>
+      </p:sp>
+      <p:sp>
+        <p:nvSpPr>
+          <p:cNvPr id="200" name="TextBox 199"/>
+          <p:cNvSpPr txBox="1"/>
+          <p:nvPr/>
+        </p:nvSpPr>
+        <p:spPr>
+          <a:xfrm>
+            <a:off x="11045952" y="5193792"/>
+            <a:ext cx="914400" cy="237744"/>
+          </a:xfrm>
+          <a:prstGeom prst="rect">
+            <a:avLst/>
+          </a:prstGeom>
+          <a:noFill/>
+        </p:spPr>
+        <p:txBody>
+          <a:bodyPr wrap="none">
+            <a:spAutoFit/>
+          </a:bodyPr>
+          <a:lstStyle/>
+          <a:p>
+            <a:pPr algn="ctr">
+              <a:defRPr sz="950" b="1">
+                <a:solidFill>
+                  <a:srgbClr val="111827"/>
+                </a:solidFill>
+                <a:latin typeface="Calibri"/>
+              </a:defRPr>
+            </a:pPr>
+            <a:r>
+              <a:t>$339K</a:t>
+            </a:r>
+          </a:p>
+        </p:txBody>
+      </p:sp>
+      <p:sp>
+        <p:nvSpPr>
+          <p:cNvPr id="201" name="Rectangle 200"/>
+          <p:cNvSpPr/>
+          <p:nvPr/>
+        </p:nvSpPr>
+        <p:spPr>
+          <a:xfrm>
+            <a:off x="6254496" y="5431536"/>
             <a:ext cx="5705856" cy="256032"/>
           </a:xfrm>
           <a:prstGeom prst="rect">
@@ -19083,13 +19270,13 @@
       </p:sp>
       <p:sp>
         <p:nvSpPr>
-          <p:cNvPr id="197" name="TextBox 196"/>
-          <p:cNvSpPr txBox="1"/>
-          <p:nvPr/>
-        </p:nvSpPr>
-        <p:spPr>
-          <a:xfrm>
-            <a:off x="6254496" y="5193792"/>
+          <p:cNvPr id="202" name="TextBox 201"/>
+          <p:cNvSpPr txBox="1"/>
+          <p:nvPr/>
+        </p:nvSpPr>
+        <p:spPr>
+          <a:xfrm>
+            <a:off x="6254496" y="5449824"/>
             <a:ext cx="411480" cy="237744"/>
           </a:xfrm>
           <a:prstGeom prst="rect">
@@ -19112,20 +19299,20 @@
               </a:defRPr>
             </a:pPr>
             <a:r>
-              <a:t>37</a:t>
-            </a:r>
-          </a:p>
-        </p:txBody>
-      </p:sp>
-      <p:sp>
-        <p:nvSpPr>
-          <p:cNvPr id="198" name="TextBox 197"/>
-          <p:cNvSpPr txBox="1"/>
-          <p:nvPr/>
-        </p:nvSpPr>
-        <p:spPr>
-          <a:xfrm>
-            <a:off x="6665976" y="5193792"/>
+              <a:t>38</a:t>
+            </a:r>
+          </a:p>
+        </p:txBody>
+      </p:sp>
+      <p:sp>
+        <p:nvSpPr>
+          <p:cNvPr id="203" name="TextBox 202"/>
+          <p:cNvSpPr txBox="1"/>
+          <p:nvPr/>
+        </p:nvSpPr>
+        <p:spPr>
+          <a:xfrm>
+            <a:off x="6665976" y="5449824"/>
             <a:ext cx="1920240" cy="237744"/>
           </a:xfrm>
           <a:prstGeom prst="rect">
@@ -19155,13 +19342,13 @@
       </p:sp>
       <p:sp>
         <p:nvSpPr>
-          <p:cNvPr id="199" name="TextBox 198"/>
-          <p:cNvSpPr txBox="1"/>
-          <p:nvPr/>
-        </p:nvSpPr>
-        <p:spPr>
-          <a:xfrm>
-            <a:off x="8586216" y="5193792"/>
+          <p:cNvPr id="204" name="TextBox 203"/>
+          <p:cNvSpPr txBox="1"/>
+          <p:nvPr/>
+        </p:nvSpPr>
+        <p:spPr>
+          <a:xfrm>
+            <a:off x="8586216" y="5449824"/>
             <a:ext cx="2459736" cy="237744"/>
           </a:xfrm>
           <a:prstGeom prst="rect">
@@ -19191,193 +19378,6 @@
       </p:sp>
       <p:sp>
         <p:nvSpPr>
-          <p:cNvPr id="200" name="TextBox 199"/>
-          <p:cNvSpPr txBox="1"/>
-          <p:nvPr/>
-        </p:nvSpPr>
-        <p:spPr>
-          <a:xfrm>
-            <a:off x="11045952" y="5193792"/>
-            <a:ext cx="914400" cy="237744"/>
-          </a:xfrm>
-          <a:prstGeom prst="rect">
-            <a:avLst/>
-          </a:prstGeom>
-          <a:noFill/>
-        </p:spPr>
-        <p:txBody>
-          <a:bodyPr wrap="none">
-            <a:spAutoFit/>
-          </a:bodyPr>
-          <a:lstStyle/>
-          <a:p>
-            <a:pPr algn="ctr">
-              <a:defRPr sz="950" b="1">
-                <a:solidFill>
-                  <a:srgbClr val="111827"/>
-                </a:solidFill>
-                <a:latin typeface="Calibri"/>
-              </a:defRPr>
-            </a:pPr>
-            <a:r>
-              <a:t>$331K</a:t>
-            </a:r>
-          </a:p>
-        </p:txBody>
-      </p:sp>
-      <p:sp>
-        <p:nvSpPr>
-          <p:cNvPr id="201" name="Rectangle 200"/>
-          <p:cNvSpPr/>
-          <p:nvPr/>
-        </p:nvSpPr>
-        <p:spPr>
-          <a:xfrm>
-            <a:off x="6254496" y="5431536"/>
-            <a:ext cx="5705856" cy="256032"/>
-          </a:xfrm>
-          <a:prstGeom prst="rect">
-            <a:avLst/>
-          </a:prstGeom>
-          <a:solidFill>
-            <a:srgbClr val="F9FAFB"/>
-          </a:solidFill>
-          <a:ln>
-            <a:noFill/>
-          </a:ln>
-        </p:spPr>
-        <p:style>
-          <a:lnRef idx="1">
-            <a:schemeClr val="accent1"/>
-          </a:lnRef>
-          <a:fillRef idx="3">
-            <a:schemeClr val="accent1"/>
-          </a:fillRef>
-          <a:effectRef idx="2">
-            <a:schemeClr val="accent1"/>
-          </a:effectRef>
-          <a:fontRef idx="minor">
-            <a:schemeClr val="lt1"/>
-          </a:fontRef>
-        </p:style>
-        <p:txBody>
-          <a:bodyPr rtlCol="0" anchor="ctr"/>
-          <a:lstStyle/>
-          <a:p>
-            <a:pPr algn="ctr"/>
-          </a:p>
-        </p:txBody>
-      </p:sp>
-      <p:sp>
-        <p:nvSpPr>
-          <p:cNvPr id="202" name="TextBox 201"/>
-          <p:cNvSpPr txBox="1"/>
-          <p:nvPr/>
-        </p:nvSpPr>
-        <p:spPr>
-          <a:xfrm>
-            <a:off x="6254496" y="5449824"/>
-            <a:ext cx="411480" cy="237744"/>
-          </a:xfrm>
-          <a:prstGeom prst="rect">
-            <a:avLst/>
-          </a:prstGeom>
-          <a:noFill/>
-        </p:spPr>
-        <p:txBody>
-          <a:bodyPr wrap="none">
-            <a:spAutoFit/>
-          </a:bodyPr>
-          <a:lstStyle/>
-          <a:p>
-            <a:pPr algn="ctr">
-              <a:defRPr sz="950" b="1">
-                <a:solidFill>
-                  <a:srgbClr val="6B7280"/>
-                </a:solidFill>
-                <a:latin typeface="Calibri"/>
-              </a:defRPr>
-            </a:pPr>
-            <a:r>
-              <a:t>38</a:t>
-            </a:r>
-          </a:p>
-        </p:txBody>
-      </p:sp>
-      <p:sp>
-        <p:nvSpPr>
-          <p:cNvPr id="203" name="TextBox 202"/>
-          <p:cNvSpPr txBox="1"/>
-          <p:nvPr/>
-        </p:nvSpPr>
-        <p:spPr>
-          <a:xfrm>
-            <a:off x="6665976" y="5449824"/>
-            <a:ext cx="1920240" cy="237744"/>
-          </a:xfrm>
-          <a:prstGeom prst="rect">
-            <a:avLst/>
-          </a:prstGeom>
-          <a:noFill/>
-        </p:spPr>
-        <p:txBody>
-          <a:bodyPr wrap="none">
-            <a:spAutoFit/>
-          </a:bodyPr>
-          <a:lstStyle/>
-          <a:p>
-            <a:pPr algn="l">
-              <a:defRPr sz="950" b="1">
-                <a:solidFill>
-                  <a:srgbClr val="111827"/>
-                </a:solidFill>
-                <a:latin typeface="Calibri"/>
-              </a:defRPr>
-            </a:pPr>
-            <a:r>
-              <a:t>Nicholas Banks</a:t>
-            </a:r>
-          </a:p>
-        </p:txBody>
-      </p:sp>
-      <p:sp>
-        <p:nvSpPr>
-          <p:cNvPr id="204" name="TextBox 203"/>
-          <p:cNvSpPr txBox="1"/>
-          <p:nvPr/>
-        </p:nvSpPr>
-        <p:spPr>
-          <a:xfrm>
-            <a:off x="8586216" y="5449824"/>
-            <a:ext cx="2459736" cy="237744"/>
-          </a:xfrm>
-          <a:prstGeom prst="rect">
-            <a:avLst/>
-          </a:prstGeom>
-          <a:noFill/>
-        </p:spPr>
-        <p:txBody>
-          <a:bodyPr wrap="none">
-            <a:spAutoFit/>
-          </a:bodyPr>
-          <a:lstStyle/>
-          <a:p>
-            <a:pPr algn="l">
-              <a:defRPr sz="950" b="0">
-                <a:solidFill>
-                  <a:srgbClr val="6B7280"/>
-                </a:solidFill>
-                <a:latin typeface="Calibri"/>
-              </a:defRPr>
-            </a:pPr>
-            <a:r>
-              <a:t>Reliance Partners, LLC</a:t>
-            </a:r>
-          </a:p>
-        </p:txBody>
-      </p:sp>
-      <p:sp>
-        <p:nvSpPr>
           <p:cNvPr id="205" name="TextBox 204"/>
           <p:cNvSpPr txBox="1"/>
           <p:nvPr/>
@@ -19407,7 +19407,7 @@
               </a:defRPr>
             </a:pPr>
             <a:r>
-              <a:t>$330K</a:t>
+              <a:t>$331K</a:t>
             </a:r>
           </a:p>
         </p:txBody>
@@ -19522,7 +19522,7 @@
               </a:defRPr>
             </a:pPr>
             <a:r>
-              <a:t>Ibrahim Mammo</a:t>
+              <a:t>Nicholas Banks</a:t>
             </a:r>
           </a:p>
         </p:txBody>
@@ -19558,7 +19558,7 @@
               </a:defRPr>
             </a:pPr>
             <a:r>
-              <a:t>Surefire Insurance Agency Corp.</a:t>
+              <a:t>Reliance Partners, LLC</a:t>
             </a:r>
           </a:p>
         </p:txBody>
@@ -19594,7 +19594,7 @@
               </a:defRPr>
             </a:pPr>
             <a:r>
-              <a:t>$323K</a:t>
+              <a:t>$330K</a:t>
             </a:r>
           </a:p>
         </p:txBody>
@@ -19922,7 +19922,7 @@
               </a:defRPr>
             </a:pPr>
             <a:r>
-              <a:t>Q2 2026 YTD (Apr 1–May 25)  |  Green = on target  |  Amber = at risk  |  Red = behind  |  Goal: ≥40 acts/wk  |  Ranked by composite OKR score</a:t>
+              <a:t>Q2 2026 YTD (Apr 1–May 26)  |  Green = on target  |  Amber = at risk  |  Red = behind  |  Goal: ≥40 acts/wk  |  Ranked by composite OKR score</a:t>
             </a:r>
           </a:p>
         </p:txBody>
@@ -19958,7 +19958,7 @@
               </a:defRPr>
             </a:pPr>
             <a:r>
-              <a:t>Generated May 25, 2026</a:t>
+              <a:t>Generated May 26, 2026</a:t>
             </a:r>
           </a:p>
         </p:txBody>
@@ -20123,7 +20123,7 @@
               </a:defRPr>
             </a:pPr>
             <a:r>
-              <a:t>Q2 2026 YTD (Apr 1–May 25)  |  Green = on target  |  Amber = at risk  |  Red = behind  |  Goal: ≥50 acts/wk  |  Ranked by composite OKR score</a:t>
+              <a:t>Q2 2026 YTD (Apr 1–May 26)  |  Green = on target  |  Amber = at risk  |  Red = behind  |  Goal: ≥50 acts/wk  |  Ranked by composite OKR score</a:t>
             </a:r>
           </a:p>
         </p:txBody>
@@ -20159,7 +20159,7 @@
               </a:defRPr>
             </a:pPr>
             <a:r>
-              <a:t>Generated May 25, 2026</a:t>
+              <a:t>Generated May 26, 2026</a:t>
             </a:r>
           </a:p>
         </p:txBody>
@@ -20324,7 +20324,7 @@
               </a:defRPr>
             </a:pPr>
             <a:r>
-              <a:t>Q2 YTD  |  Apr 1–May 25  |  BDMs Only  |  Goal: 40 acts/wk  |  Emails excluded</a:t>
+              <a:t>Q2 YTD  |  Apr 1–May 26  |  BDMs Only  |  Goal: 40 acts/wk  |  Emails excluded</a:t>
             </a:r>
           </a:p>
         </p:txBody>
@@ -20360,7 +20360,7 @@
               </a:defRPr>
             </a:pPr>
             <a:r>
-              <a:t>Generated May 25, 2026</a:t>
+              <a:t>Generated May 26, 2026</a:t>
             </a:r>
           </a:p>
         </p:txBody>
@@ -20727,7 +20727,7 @@
               </a:defRPr>
             </a:pPr>
             <a:r>
-              <a:t>May 25-25</a:t>
+              <a:t>May 25-26</a:t>
             </a:r>
           </a:p>
         </p:txBody>
@@ -23570,7 +23570,7 @@
             <a:avLst/>
           </a:prstGeom>
           <a:solidFill>
-            <a:srgbClr val="D1D5DB"/>
+            <a:srgbClr val="DC2626"/>
           </a:solidFill>
           <a:ln>
             <a:noFill/>
@@ -23629,7 +23629,7 @@
               </a:defRPr>
             </a:pPr>
             <a:r>
-              <a:t>0</a:t>
+              <a:t>8</a:t>
             </a:r>
           </a:p>
         </p:txBody>
@@ -26505,7 +26505,7 @@
               </a:defRPr>
             </a:pPr>
             <a:r>
-              <a:t>399</a:t>
+              <a:t>406</a:t>
             </a:r>
           </a:p>
         </p:txBody>
@@ -26541,7 +26541,7 @@
               </a:defRPr>
             </a:pPr>
             <a:r>
-              <a:t>20</a:t>
+              <a:t>21</a:t>
             </a:r>
           </a:p>
         </p:txBody>
@@ -26613,7 +26613,7 @@
               </a:defRPr>
             </a:pPr>
             <a:r>
-              <a:t>419</a:t>
+              <a:t>427</a:t>
             </a:r>
           </a:p>
         </p:txBody>
@@ -27445,7 +27445,7 @@
               </a:defRPr>
             </a:pPr>
             <a:r>
-              <a:t>Q2 YTD  |  Apr 1–May 25  |  BDAs Only  |  Goal: 50 acts/wk  |  Emails excluded</a:t>
+              <a:t>Q2 YTD  |  Apr 1–May 26  |  BDAs Only  |  Goal: 50 acts/wk  |  Emails excluded</a:t>
             </a:r>
           </a:p>
         </p:txBody>
@@ -27481,7 +27481,7 @@
               </a:defRPr>
             </a:pPr>
             <a:r>
-              <a:t>Generated May 25, 2026</a:t>
+              <a:t>Generated May 26, 2026</a:t>
             </a:r>
           </a:p>
         </p:txBody>
@@ -27848,7 +27848,7 @@
               </a:defRPr>
             </a:pPr>
             <a:r>
-              <a:t>May 25-25</a:t>
+              <a:t>May 25-26</a:t>
             </a:r>
           </a:p>
         </p:txBody>
@@ -28493,7 +28493,7 @@
             <a:avLst/>
           </a:prstGeom>
           <a:solidFill>
-            <a:srgbClr val="D1D5DB"/>
+            <a:srgbClr val="DC2626"/>
           </a:solidFill>
           <a:ln>
             <a:noFill/>
@@ -28552,7 +28552,7 @@
               </a:defRPr>
             </a:pPr>
             <a:r>
-              <a:t>0</a:t>
+              <a:t>1</a:t>
             </a:r>
           </a:p>
         </p:txBody>
@@ -30475,7 +30475,7 @@
             <a:avLst/>
           </a:prstGeom>
           <a:solidFill>
-            <a:srgbClr val="D1D5DB"/>
+            <a:srgbClr val="DC2626"/>
           </a:solidFill>
           <a:ln>
             <a:noFill/>
@@ -30534,7 +30534,7 @@
               </a:defRPr>
             </a:pPr>
             <a:r>
-              <a:t>0</a:t>
+              <a:t>1</a:t>
             </a:r>
           </a:p>
         </p:txBody>
@@ -31713,7 +31713,7 @@
               </a:defRPr>
             </a:pPr>
             <a:r>
-              <a:t>350</a:t>
+              <a:t>351</a:t>
             </a:r>
           </a:p>
         </p:txBody>
@@ -31821,7 +31821,7 @@
               </a:defRPr>
             </a:pPr>
             <a:r>
-              <a:t>360</a:t>
+              <a:t>361</a:t>
             </a:r>
           </a:p>
         </p:txBody>
@@ -32116,7 +32116,7 @@
               </a:defRPr>
             </a:pPr>
             <a:r>
-              <a:t>11</a:t>
+              <a:t>12</a:t>
             </a:r>
           </a:p>
         </p:txBody>
@@ -32404,7 +32404,7 @@
               </a:defRPr>
             </a:pPr>
             <a:r>
-              <a:t>28</a:t>
+              <a:t>29</a:t>
             </a:r>
           </a:p>
         </p:txBody>
@@ -32699,7 +32699,7 @@
               </a:defRPr>
             </a:pPr>
             <a:r>
-              <a:t>12</a:t>
+              <a:t>13</a:t>
             </a:r>
           </a:p>
         </p:txBody>
@@ -32771,7 +32771,7 @@
               </a:defRPr>
             </a:pPr>
             <a:r>
-              <a:t>234</a:t>
+              <a:t>235</a:t>
             </a:r>
           </a:p>
         </p:txBody>
@@ -32807,7 +32807,7 @@
               </a:defRPr>
             </a:pPr>
             <a:r>
-              <a:t>39.0</a:t>
+              <a:t>39.2</a:t>
             </a:r>
           </a:p>
         </p:txBody>
@@ -33308,7 +33308,7 @@
               </a:defRPr>
             </a:pPr>
             <a:r>
-              <a:t>Generated May 25, 2026</a:t>
+              <a:t>Generated May 26, 2026</a:t>
             </a:r>
           </a:p>
         </p:txBody>
@@ -33999,7 +33999,7 @@
               </a:defRPr>
             </a:pPr>
             <a:r>
-              <a:t>6954</a:t>
+              <a:t>6966</a:t>
             </a:r>
           </a:p>
         </p:txBody>
@@ -34035,7 +34035,7 @@
               </a:defRPr>
             </a:pPr>
             <a:r>
-              <a:t>478</a:t>
+              <a:t>481</a:t>
             </a:r>
           </a:p>
         </p:txBody>
@@ -34071,7 +34071,7 @@
               </a:defRPr>
             </a:pPr>
             <a:r>
-              <a:t>$16.4M</a:t>
+              <a:t>$16.7M</a:t>
             </a:r>
           </a:p>
         </p:txBody>
@@ -34143,7 +34143,7 @@
               </a:defRPr>
             </a:pPr>
             <a:r>
-              <a:t>$3.9M</a:t>
+              <a:t>$4.0M</a:t>
             </a:r>
           </a:p>
         </p:txBody>
@@ -34438,7 +34438,7 @@
               </a:defRPr>
             </a:pPr>
             <a:r>
-              <a:t>3347</a:t>
+              <a:t>3356</a:t>
             </a:r>
           </a:p>
         </p:txBody>
@@ -34474,7 +34474,7 @@
               </a:defRPr>
             </a:pPr>
             <a:r>
-              <a:t>334</a:t>
+              <a:t>339</a:t>
             </a:r>
           </a:p>
         </p:txBody>
@@ -34510,7 +34510,7 @@
               </a:defRPr>
             </a:pPr>
             <a:r>
-              <a:t>$9.3M</a:t>
+              <a:t>$9.4M</a:t>
             </a:r>
           </a:p>
         </p:txBody>
@@ -34834,7 +34834,7 @@
               </a:defRPr>
             </a:pPr>
             <a:r>
-              <a:t>5311</a:t>
+              <a:t>5374</a:t>
             </a:r>
           </a:p>
         </p:txBody>
@@ -34870,7 +34870,7 @@
               </a:defRPr>
             </a:pPr>
             <a:r>
-              <a:t>297</a:t>
+              <a:t>302</a:t>
             </a:r>
           </a:p>
         </p:txBody>
@@ -34906,7 +34906,7 @@
               </a:defRPr>
             </a:pPr>
             <a:r>
-              <a:t>$8.7M</a:t>
+              <a:t>$8.8M</a:t>
             </a:r>
           </a:p>
         </p:txBody>
@@ -35273,7 +35273,7 @@
               </a:defRPr>
             </a:pPr>
             <a:r>
-              <a:t>3241</a:t>
+              <a:t>3244</a:t>
             </a:r>
           </a:p>
         </p:txBody>
@@ -35309,7 +35309,7 @@
               </a:defRPr>
             </a:pPr>
             <a:r>
-              <a:t>256</a:t>
+              <a:t>255</a:t>
             </a:r>
           </a:p>
         </p:txBody>
@@ -35669,7 +35669,7 @@
               </a:defRPr>
             </a:pPr>
             <a:r>
-              <a:t>1810</a:t>
+              <a:t>1811</a:t>
             </a:r>
           </a:p>
         </p:txBody>
@@ -35705,7 +35705,7 @@
               </a:defRPr>
             </a:pPr>
             <a:r>
-              <a:t>124</a:t>
+              <a:t>126</a:t>
             </a:r>
           </a:p>
         </p:txBody>
@@ -35741,7 +35741,7 @@
               </a:defRPr>
             </a:pPr>
             <a:r>
-              <a:t>$4.1M</a:t>
+              <a:t>$4.2M</a:t>
             </a:r>
           </a:p>
         </p:txBody>
@@ -36187,7 +36187,7 @@
               </a:defRPr>
             </a:pPr>
             <a:r>
-              <a:t>3939</a:t>
+              <a:t>3956</a:t>
             </a:r>
           </a:p>
         </p:txBody>
@@ -36223,7 +36223,7 @@
               </a:defRPr>
             </a:pPr>
             <a:r>
-              <a:t>103</a:t>
+              <a:t>107</a:t>
             </a:r>
           </a:p>
         </p:txBody>
@@ -36259,7 +36259,7 @@
               </a:defRPr>
             </a:pPr>
             <a:r>
-              <a:t>$2.5M</a:t>
+              <a:t>$2.6M</a:t>
             </a:r>
           </a:p>
         </p:txBody>
@@ -36583,7 +36583,7 @@
               </a:defRPr>
             </a:pPr>
             <a:r>
-              <a:t>2689</a:t>
+              <a:t>2706</a:t>
             </a:r>
           </a:p>
         </p:txBody>
@@ -36619,7 +36619,7 @@
               </a:defRPr>
             </a:pPr>
             <a:r>
-              <a:t>51</a:t>
+              <a:t>50</a:t>
             </a:r>
           </a:p>
         </p:txBody>
@@ -37022,7 +37022,7 @@
               </a:defRPr>
             </a:pPr>
             <a:r>
-              <a:t>1563</a:t>
+              <a:t>1569</a:t>
             </a:r>
           </a:p>
         </p:txBody>
@@ -37058,7 +37058,7 @@
               </a:defRPr>
             </a:pPr>
             <a:r>
-              <a:t>34</a:t>
+              <a:t>33</a:t>
             </a:r>
           </a:p>
         </p:txBody>
@@ -37094,7 +37094,7 @@
               </a:defRPr>
             </a:pPr>
             <a:r>
-              <a:t>$1.2M</a:t>
+              <a:t>$1.1M</a:t>
             </a:r>
           </a:p>
         </p:txBody>
@@ -37418,7 +37418,7 @@
               </a:defRPr>
             </a:pPr>
             <a:r>
-              <a:t>910</a:t>
+              <a:t>912</a:t>
             </a:r>
           </a:p>
         </p:txBody>
@@ -37454,7 +37454,7 @@
               </a:defRPr>
             </a:pPr>
             <a:r>
-              <a:t>50</a:t>
+              <a:t>51</a:t>
             </a:r>
           </a:p>
         </p:txBody>
@@ -37857,7 +37857,7 @@
               </a:defRPr>
             </a:pPr>
             <a:r>
-              <a:t>595</a:t>
+              <a:t>598</a:t>
             </a:r>
           </a:p>
         </p:txBody>
@@ -38375,7 +38375,7 @@
               </a:defRPr>
             </a:pPr>
             <a:r>
-              <a:t>7428</a:t>
+              <a:t>7458</a:t>
             </a:r>
           </a:p>
         </p:txBody>
@@ -38411,7 +38411,7 @@
               </a:defRPr>
             </a:pPr>
             <a:r>
-              <a:t>287</a:t>
+              <a:t>288</a:t>
             </a:r>
           </a:p>
         </p:txBody>
@@ -38519,7 +38519,7 @@
               </a:defRPr>
             </a:pPr>
             <a:r>
-              <a:t>$2.7M</a:t>
+              <a:t>$2.8M</a:t>
             </a:r>
           </a:p>
         </p:txBody>
@@ -39134,7 +39134,7 @@
               </a:defRPr>
             </a:pPr>
             <a:r>
-              <a:t>Retail-vertical agencies in each rep's HubSpot portfolio with zero 2026 submissions  |  Refreshed 2026-05-25</a:t>
+              <a:t>Retail-vertical agencies in each rep's HubSpot portfolio with zero 2026 submissions  |  Refreshed 2026-05-26</a:t>
             </a:r>
           </a:p>
         </p:txBody>
@@ -39170,7 +39170,7 @@
               </a:defRPr>
             </a:pPr>
             <a:r>
-              <a:t>Generated May 25, 2026</a:t>
+              <a:t>Generated May 26, 2026</a:t>
             </a:r>
           </a:p>
         </p:txBody>
@@ -41711,7 +41711,7 @@
               </a:defRPr>
             </a:pPr>
             <a:r>
-              <a:t>Generated May 25, 2026</a:t>
+              <a:t>Generated May 26, 2026</a:t>
             </a:r>
           </a:p>
         </p:txBody>
@@ -41876,7 +41876,7 @@
               </a:defRPr>
             </a:pPr>
             <a:r>
-              <a:t>Ranked by Q2 GWP (left) and Q2 Submissions (right)  ·  Mint-shaded row = new vs last week’s deck  ·  Apr 1–May 25</a:t>
+              <a:t>Ranked by Q2 GWP (left) and Q2 Submissions (right)  ·  Mint-shaded row = new vs last week’s deck  ·  Apr 1–May 26</a:t>
             </a:r>
           </a:p>
         </p:txBody>
@@ -41912,7 +41912,7 @@
               </a:defRPr>
             </a:pPr>
             <a:r>
-              <a:t>Generated May 25, 2026</a:t>
+              <a:t>Generated May 26, 2026</a:t>
             </a:r>
           </a:p>
         </p:txBody>
@@ -42365,7 +42365,7 @@
               </a:defRPr>
             </a:pPr>
             <a:r>
-              <a:t>$3.1M</a:t>
+              <a:t>$3.2M</a:t>
             </a:r>
           </a:p>
         </p:txBody>
@@ -42480,7 +42480,7 @@
               </a:defRPr>
             </a:pPr>
             <a:r>
-              <a:t>Derek J.</a:t>
+              <a:t>Christopher H.</a:t>
             </a:r>
           </a:p>
         </p:txBody>
@@ -42516,7 +42516,7 @@
               </a:defRPr>
             </a:pPr>
             <a:r>
-              <a:t>Reliance Partners, LLC</a:t>
+              <a:t>Commercial Trucking Insurance Agency LLC</a:t>
             </a:r>
           </a:p>
         </p:txBody>
@@ -42552,7 +42552,7 @@
               </a:defRPr>
             </a:pPr>
             <a:r>
-              <a:t>$1.9M</a:t>
+              <a:t>$2.0M</a:t>
             </a:r>
           </a:p>
         </p:txBody>
@@ -42667,7 +42667,7 @@
               </a:defRPr>
             </a:pPr>
             <a:r>
-              <a:t>Christopher H.</a:t>
+              <a:t>Derek J.</a:t>
             </a:r>
           </a:p>
         </p:txBody>
@@ -42703,7 +42703,7 @@
               </a:defRPr>
             </a:pPr>
             <a:r>
-              <a:t>Commercial Trucking Insurance Agency LLC</a:t>
+              <a:t>Reliance Partners, LLC</a:t>
             </a:r>
           </a:p>
         </p:txBody>
@@ -43300,7 +43300,7 @@
               </a:defRPr>
             </a:pPr>
             <a:r>
-              <a:t>$1.6M</a:t>
+              <a:t>$1.5M</a:t>
             </a:r>
           </a:p>
         </p:txBody>
@@ -43415,7 +43415,7 @@
               </a:defRPr>
             </a:pPr>
             <a:r>
-              <a:t>Derrick L.</a:t>
+              <a:t>Derek J.</a:t>
             </a:r>
           </a:p>
         </p:txBody>
@@ -43451,7 +43451,7 @@
               </a:defRPr>
             </a:pPr>
             <a:r>
-              <a:t>American Fleet Insurance</a:t>
+              <a:t>Safeline Insurance Agency, Inc.</a:t>
             </a:r>
           </a:p>
         </p:txBody>
@@ -43602,7 +43602,7 @@
               </a:defRPr>
             </a:pPr>
             <a:r>
-              <a:t>Derek J.</a:t>
+              <a:t>Derrick L.</a:t>
             </a:r>
           </a:p>
         </p:txBody>
@@ -43638,7 +43638,7 @@
               </a:defRPr>
             </a:pPr>
             <a:r>
-              <a:t>Safeline Insurance Agency, Inc.</a:t>
+              <a:t>American Fleet Insurance</a:t>
             </a:r>
           </a:p>
         </p:txBody>
@@ -44350,7 +44350,7 @@
               </a:defRPr>
             </a:pPr>
             <a:r>
-              <a:t>Ron D.</a:t>
+              <a:t>Alexis B.</a:t>
             </a:r>
           </a:p>
         </p:txBody>
@@ -44386,7 +44386,7 @@
               </a:defRPr>
             </a:pPr>
             <a:r>
-              <a:t>Valion Security LLC</a:t>
+              <a:t>A.S.I.A Inc</a:t>
             </a:r>
           </a:p>
         </p:txBody>
@@ -44422,7 +44422,7 @@
               </a:defRPr>
             </a:pPr>
             <a:r>
-              <a:t>$982K</a:t>
+              <a:t>$1.1M</a:t>
             </a:r>
           </a:p>
         </p:txBody>
@@ -44537,7 +44537,7 @@
               </a:defRPr>
             </a:pPr>
             <a:r>
-              <a:t>Alexis B.</a:t>
+              <a:t>Derek J.</a:t>
             </a:r>
           </a:p>
         </p:txBody>
@@ -44573,7 +44573,7 @@
               </a:defRPr>
             </a:pPr>
             <a:r>
-              <a:t>A.S.I.A Inc</a:t>
+              <a:t>Surefire Insurance Agency Corp.</a:t>
             </a:r>
           </a:p>
         </p:txBody>
@@ -44609,7 +44609,7 @@
               </a:defRPr>
             </a:pPr>
             <a:r>
-              <a:t>$962K</a:t>
+              <a:t>$1.0M</a:t>
             </a:r>
           </a:p>
         </p:txBody>
@@ -44724,7 +44724,7 @@
               </a:defRPr>
             </a:pPr>
             <a:r>
-              <a:t>Kurt B.</a:t>
+              <a:t>Ron D.</a:t>
             </a:r>
           </a:p>
         </p:txBody>
@@ -44760,7 +44760,7 @@
               </a:defRPr>
             </a:pPr>
             <a:r>
-              <a:t>Fino Services LLC</a:t>
+              <a:t>Valion Security LLC</a:t>
             </a:r>
           </a:p>
         </p:txBody>
@@ -44796,7 +44796,7 @@
               </a:defRPr>
             </a:pPr>
             <a:r>
-              <a:t>$896K</a:t>
+              <a:t>$982K</a:t>
             </a:r>
           </a:p>
         </p:txBody>
@@ -44911,7 +44911,7 @@
               </a:defRPr>
             </a:pPr>
             <a:r>
-              <a:t>Derek J.</a:t>
+              <a:t>Kurt B.</a:t>
             </a:r>
           </a:p>
         </p:txBody>
@@ -44947,7 +44947,7 @@
               </a:defRPr>
             </a:pPr>
             <a:r>
-              <a:t>Surefire Insurance Agency Corp.</a:t>
+              <a:t>Fino Services LLC</a:t>
             </a:r>
           </a:p>
         </p:txBody>
@@ -44983,7 +44983,7 @@
               </a:defRPr>
             </a:pPr>
             <a:r>
-              <a:t>$893K</a:t>
+              <a:t>$934K</a:t>
             </a:r>
           </a:p>
         </p:txBody>
@@ -45170,7 +45170,7 @@
               </a:defRPr>
             </a:pPr>
             <a:r>
-              <a:t>$797K</a:t>
+              <a:t>$828K</a:t>
             </a:r>
           </a:p>
         </p:txBody>
@@ -45544,7 +45544,7 @@
               </a:defRPr>
             </a:pPr>
             <a:r>
-              <a:t>$722K</a:t>
+              <a:t>$743K</a:t>
             </a:r>
           </a:p>
         </p:txBody>
@@ -45659,7 +45659,7 @@
               </a:defRPr>
             </a:pPr>
             <a:r>
-              <a:t>Derek J.</a:t>
+              <a:t>Derrick L.</a:t>
             </a:r>
           </a:p>
         </p:txBody>
@@ -45695,7 +45695,7 @@
               </a:defRPr>
             </a:pPr>
             <a:r>
-              <a:t>Sedge Insurance Agency LLC</a:t>
+              <a:t>Justin Wilson</a:t>
             </a:r>
           </a:p>
         </p:txBody>
@@ -45731,7 +45731,7 @@
               </a:defRPr>
             </a:pPr>
             <a:r>
-              <a:t>$582K</a:t>
+              <a:t>$640K</a:t>
             </a:r>
           </a:p>
         </p:txBody>
@@ -45846,7 +45846,7 @@
               </a:defRPr>
             </a:pPr>
             <a:r>
-              <a:t>Derrick L.</a:t>
+              <a:t>Derek J.</a:t>
             </a:r>
           </a:p>
         </p:txBody>
@@ -45882,7 +45882,7 @@
               </a:defRPr>
             </a:pPr>
             <a:r>
-              <a:t>Justin Wilson</a:t>
+              <a:t>Sedge Insurance Agency LLC</a:t>
             </a:r>
           </a:p>
         </p:txBody>
@@ -45918,7 +45918,7 @@
               </a:defRPr>
             </a:pPr>
             <a:r>
-              <a:t>$559K</a:t>
+              <a:t>$582K</a:t>
             </a:r>
           </a:p>
         </p:txBody>
@@ -46371,7 +46371,7 @@
               </a:defRPr>
             </a:pPr>
             <a:r>
-              <a:t>2196</a:t>
+              <a:t>2195</a:t>
             </a:r>
           </a:p>
         </p:txBody>
@@ -46558,7 +46558,7 @@
               </a:defRPr>
             </a:pPr>
             <a:r>
-              <a:t>2042</a:t>
+              <a:t>2061</a:t>
             </a:r>
           </a:p>
         </p:txBody>
@@ -46932,7 +46932,7 @@
               </a:defRPr>
             </a:pPr>
             <a:r>
-              <a:t>1261</a:t>
+              <a:t>1296</a:t>
             </a:r>
           </a:p>
         </p:txBody>
@@ -47119,7 +47119,7 @@
               </a:defRPr>
             </a:pPr>
             <a:r>
-              <a:t>1174</a:t>
+              <a:t>1175</a:t>
             </a:r>
           </a:p>
         </p:txBody>
@@ -47306,7 +47306,7 @@
               </a:defRPr>
             </a:pPr>
             <a:r>
-              <a:t>1010</a:t>
+              <a:t>1009</a:t>
             </a:r>
           </a:p>
         </p:txBody>
@@ -47680,7 +47680,7 @@
               </a:defRPr>
             </a:pPr>
             <a:r>
-              <a:t>915</a:t>
+              <a:t>928</a:t>
             </a:r>
           </a:p>
         </p:txBody>
@@ -48054,7 +48054,7 @@
               </a:defRPr>
             </a:pPr>
             <a:r>
-              <a:t>553</a:t>
+              <a:t>554</a:t>
             </a:r>
           </a:p>
         </p:txBody>
@@ -48241,7 +48241,7 @@
               </a:defRPr>
             </a:pPr>
             <a:r>
-              <a:t>526</a:t>
+              <a:t>527</a:t>
             </a:r>
           </a:p>
         </p:txBody>
@@ -48428,7 +48428,7 @@
               </a:defRPr>
             </a:pPr>
             <a:r>
-              <a:t>497</a:t>
+              <a:t>508</a:t>
             </a:r>
           </a:p>
         </p:txBody>
@@ -49363,7 +49363,7 @@
               </a:defRPr>
             </a:pPr>
             <a:r>
-              <a:t>358</a:t>
+              <a:t>361</a:t>
             </a:r>
           </a:p>
         </p:txBody>
@@ -49737,7 +49737,7 @@
               </a:defRPr>
             </a:pPr>
             <a:r>
-              <a:t>346</a:t>
+              <a:t>347</a:t>
             </a:r>
           </a:p>
         </p:txBody>

</xml_diff>

<commit_message>
Fix ww-table contrast in dark mode (hit ratio + per-truck score were unreadable) 2026-05-29 01:10
</commit_message>
<xml_diff>
--- a/generated/Sales Dashboards/BD Rep Scoreboard.pptx
+++ b/generated/Sales Dashboards/BD Rep Scoreboard.pptx
@@ -5019,7 +5019,7 @@
               </a:defRPr>
             </a:pPr>
             <a:r>
-              <a:t>$19.9M</a:t>
+              <a:t>$20.7M</a:t>
             </a:r>
           </a:p>
         </p:txBody>
@@ -5055,7 +5055,7 @@
               </a:defRPr>
             </a:pPr>
             <a:r>
-              <a:t>Team GWP Q2 YTD  |  Proj. $30.7M</a:t>
+              <a:t>Team GWP Q2 YTD  |  Proj. $32.0M</a:t>
             </a:r>
           </a:p>
         </p:txBody>
@@ -5134,7 +5134,7 @@
               </a:defRPr>
             </a:pPr>
             <a:r>
-              <a:t>Pacing 167% of Q1 Final</a:t>
+              <a:t>Pacing 173% of Q1 Final</a:t>
             </a:r>
           </a:p>
         </p:txBody>
@@ -5758,7 +5758,7 @@
               </a:defRPr>
             </a:pPr>
             <a:r>
-              <a:t>▲ $1.3M vs Apr pace</a:t>
+              <a:t>▲ $2.2M vs Apr pace</a:t>
             </a:r>
           </a:p>
         </p:txBody>
@@ -6071,7 +6071,7 @@
               </a:defRPr>
             </a:pPr>
             <a:r>
-              <a:t>$28.5M</a:t>
+              <a:t>$29.4M</a:t>
             </a:r>
           </a:p>
         </p:txBody>
@@ -6179,7 +6179,7 @@
               </a:defRPr>
             </a:pPr>
             <a:r>
-              <a:t>Renewals (22%)</a:t>
+              <a:t>Renewals (21%)</a:t>
             </a:r>
           </a:p>
         </p:txBody>
@@ -6215,7 +6215,7 @@
               </a:defRPr>
             </a:pPr>
             <a:r>
-              <a:t>$2.9M</a:t>
+              <a:t>$3.0M</a:t>
             </a:r>
           </a:p>
         </p:txBody>
@@ -6787,7 +6787,7 @@
               </a:defRPr>
             </a:pPr>
             <a:r>
-              <a:t>MTD (May):  $10.28M written  ·  $10.99M pace  ·  29/31 days elapsed</a:t>
+              <a:t>MTD (May):  $11.10M written  ·  $11.87M pace  ·  29/31 days elapsed</a:t>
             </a:r>
           </a:p>
         </p:txBody>
@@ -12488,7 +12488,7 @@
               </a:defRPr>
             </a:pPr>
             <a:r>
-              <a:t>$3.3M</a:t>
+              <a:t>$3.4M</a:t>
             </a:r>
           </a:p>
         </p:txBody>
@@ -12790,7 +12790,7 @@
               </a:defRPr>
             </a:pPr>
             <a:r>
-              <a:t>Justin Feaster</a:t>
+              <a:t>Gurashish Bedi</a:t>
             </a:r>
           </a:p>
         </p:txBody>
@@ -12826,7 +12826,7 @@
               </a:defRPr>
             </a:pPr>
             <a:r>
-              <a:t>American Fleet Insurance</a:t>
+              <a:t>Commercial Trucking Insurance Agen…</a:t>
             </a:r>
           </a:p>
         </p:txBody>
@@ -12977,7 +12977,7 @@
               </a:defRPr>
             </a:pPr>
             <a:r>
-              <a:t>Gurashish Bedi</a:t>
+              <a:t>Justin Feaster</a:t>
             </a:r>
           </a:p>
         </p:txBody>
@@ -13013,7 +13013,7 @@
               </a:defRPr>
             </a:pPr>
             <a:r>
-              <a:t>Commercial Trucking Insurance Agen…</a:t>
+              <a:t>American Fleet Insurance</a:t>
             </a:r>
           </a:p>
         </p:txBody>
@@ -13049,7 +13049,7 @@
               </a:defRPr>
             </a:pPr>
             <a:r>
-              <a:t>$1.5M</a:t>
+              <a:t>$1.6M</a:t>
             </a:r>
           </a:p>
         </p:txBody>
@@ -13236,7 +13236,7 @@
               </a:defRPr>
             </a:pPr>
             <a:r>
-              <a:t>$1.4M</a:t>
+              <a:t>$1.5M</a:t>
             </a:r>
           </a:p>
         </p:txBody>
@@ -13610,7 +13610,7 @@
               </a:defRPr>
             </a:pPr>
             <a:r>
-              <a:t>$1.1M</a:t>
+              <a:t>$1.2M</a:t>
             </a:r>
           </a:p>
         </p:txBody>
@@ -13984,7 +13984,7 @@
               </a:defRPr>
             </a:pPr>
             <a:r>
-              <a:t>$838K</a:t>
+              <a:t>$860K</a:t>
             </a:r>
           </a:p>
         </p:txBody>
@@ -14473,7 +14473,7 @@
               </a:defRPr>
             </a:pPr>
             <a:r>
-              <a:t>Larisa Davtyan</a:t>
+              <a:t>No Name Given Ankush</a:t>
             </a:r>
           </a:p>
         </p:txBody>
@@ -14509,7 +14509,7 @@
               </a:defRPr>
             </a:pPr>
             <a:r>
-              <a:t>Safeline Insurance Agency, Inc.</a:t>
+              <a:t>Vintage Insurance Agency Inc (The)</a:t>
             </a:r>
           </a:p>
         </p:txBody>
@@ -14545,7 +14545,7 @@
               </a:defRPr>
             </a:pPr>
             <a:r>
-              <a:t>$700K</a:t>
+              <a:t>$698K</a:t>
             </a:r>
           </a:p>
         </p:txBody>
@@ -14660,7 +14660,7 @@
               </a:defRPr>
             </a:pPr>
             <a:r>
-              <a:t>Shubham Kamra</a:t>
+              <a:t>Larisa Davtyan</a:t>
             </a:r>
           </a:p>
         </p:txBody>
@@ -14696,7 +14696,7 @@
               </a:defRPr>
             </a:pPr>
             <a:r>
-              <a:t>A.S.I.A Inc</a:t>
+              <a:t>Safeline Insurance Agency, Inc.</a:t>
             </a:r>
           </a:p>
         </p:txBody>
@@ -14732,7 +14732,7 @@
               </a:defRPr>
             </a:pPr>
             <a:r>
-              <a:t>$688K</a:t>
+              <a:t>$698K</a:t>
             </a:r>
           </a:p>
         </p:txBody>
@@ -14847,7 +14847,7 @@
               </a:defRPr>
             </a:pPr>
             <a:r>
-              <a:t>No Name Given Ankush</a:t>
+              <a:t>Shubham Kamra</a:t>
             </a:r>
           </a:p>
         </p:txBody>
@@ -14883,7 +14883,7 @@
               </a:defRPr>
             </a:pPr>
             <a:r>
-              <a:t>Vintage Insurance Agency Inc (The)</a:t>
+              <a:t>A.S.I.A Inc</a:t>
             </a:r>
           </a:p>
         </p:txBody>
@@ -14919,7 +14919,7 @@
               </a:defRPr>
             </a:pPr>
             <a:r>
-              <a:t>$683K</a:t>
+              <a:t>$688K</a:t>
             </a:r>
           </a:p>
         </p:txBody>
@@ -15221,7 +15221,7 @@
               </a:defRPr>
             </a:pPr>
             <a:r>
-              <a:t>Anastasiya Nabokov</a:t>
+              <a:t>Diego Giraldo</a:t>
             </a:r>
           </a:p>
         </p:txBody>
@@ -15257,7 +15257,7 @@
               </a:defRPr>
             </a:pPr>
             <a:r>
-              <a:t>Drive Safe Group LLC</a:t>
+              <a:t>Horizons Insurance And Financial S…</a:t>
             </a:r>
           </a:p>
         </p:txBody>
@@ -15293,7 +15293,7 @@
               </a:defRPr>
             </a:pPr>
             <a:r>
-              <a:t>$589K</a:t>
+              <a:t>$591K</a:t>
             </a:r>
           </a:p>
         </p:txBody>
@@ -15408,7 +15408,7 @@
               </a:defRPr>
             </a:pPr>
             <a:r>
-              <a:t>Diego Giraldo</a:t>
+              <a:t>Anastasiya Nabokov</a:t>
             </a:r>
           </a:p>
         </p:txBody>
@@ -15444,7 +15444,7 @@
               </a:defRPr>
             </a:pPr>
             <a:r>
-              <a:t>Horizons Insurance And Financial S…</a:t>
+              <a:t>Drive Safe Group LLC</a:t>
             </a:r>
           </a:p>
         </p:txBody>
@@ -15480,7 +15480,7 @@
               </a:defRPr>
             </a:pPr>
             <a:r>
-              <a:t>$565K</a:t>
+              <a:t>$589K</a:t>
             </a:r>
           </a:p>
         </p:txBody>
@@ -15667,7 +15667,7 @@
               </a:defRPr>
             </a:pPr>
             <a:r>
-              <a:t>$548K</a:t>
+              <a:t>$551K</a:t>
             </a:r>
           </a:p>
         </p:txBody>
@@ -16156,7 +16156,7 @@
               </a:defRPr>
             </a:pPr>
             <a:r>
-              <a:t>Daven Loomba</a:t>
+              <a:t>Scott Procops</a:t>
             </a:r>
           </a:p>
         </p:txBody>
@@ -16192,7 +16192,7 @@
               </a:defRPr>
             </a:pPr>
             <a:r>
-              <a:t>GoldenEra Insurance Agency</a:t>
+              <a:t>Specialty Coverage Insurance Agenc…</a:t>
             </a:r>
           </a:p>
         </p:txBody>
@@ -16228,7 +16228,7 @@
               </a:defRPr>
             </a:pPr>
             <a:r>
-              <a:t>$505K</a:t>
+              <a:t>$512K</a:t>
             </a:r>
           </a:p>
         </p:txBody>
@@ -16343,7 +16343,7 @@
               </a:defRPr>
             </a:pPr>
             <a:r>
-              <a:t>Scott Procops</a:t>
+              <a:t>Daven Loomba</a:t>
             </a:r>
           </a:p>
         </p:txBody>
@@ -16379,7 +16379,7 @@
               </a:defRPr>
             </a:pPr>
             <a:r>
-              <a:t>Specialty Coverage Insurance Agenc…</a:t>
+              <a:t>GoldenEra Insurance Agency</a:t>
             </a:r>
           </a:p>
         </p:txBody>
@@ -16415,7 +16415,7 @@
               </a:defRPr>
             </a:pPr>
             <a:r>
-              <a:t>$493K</a:t>
+              <a:t>$505K</a:t>
             </a:r>
           </a:p>
         </p:txBody>
@@ -16976,7 +16976,7 @@
               </a:defRPr>
             </a:pPr>
             <a:r>
-              <a:t>$442K</a:t>
+              <a:t>$438K</a:t>
             </a:r>
           </a:p>
         </p:txBody>
@@ -18213,7 +18213,7 @@
               </a:defRPr>
             </a:pPr>
             <a:r>
-              <a:t>Inderjit Singh</a:t>
+              <a:t>Venizelos Papadopulos</a:t>
             </a:r>
           </a:p>
         </p:txBody>
@@ -18249,7 +18249,7 @@
               </a:defRPr>
             </a:pPr>
             <a:r>
-              <a:t>American Insurance Agency LLC</a:t>
+              <a:t>Exclusive Financial Services, Inc</a:t>
             </a:r>
           </a:p>
         </p:txBody>
@@ -18285,7 +18285,7 @@
               </a:defRPr>
             </a:pPr>
             <a:r>
-              <a:t>$375K</a:t>
+              <a:t>$380K</a:t>
             </a:r>
           </a:p>
         </p:txBody>
@@ -18400,7 +18400,7 @@
               </a:defRPr>
             </a:pPr>
             <a:r>
-              <a:t>Michael Su</a:t>
+              <a:t>Inderjit Singh</a:t>
             </a:r>
           </a:p>
         </p:txBody>
@@ -18436,7 +18436,7 @@
               </a:defRPr>
             </a:pPr>
             <a:r>
-              <a:t>Jtc Insurance Agency, Inc.</a:t>
+              <a:t>American Insurance Agency LLC</a:t>
             </a:r>
           </a:p>
         </p:txBody>
@@ -18472,7 +18472,7 @@
               </a:defRPr>
             </a:pPr>
             <a:r>
-              <a:t>$368K</a:t>
+              <a:t>$375K</a:t>
             </a:r>
           </a:p>
         </p:txBody>
@@ -18486,6 +18486,193 @@
         <p:spPr>
           <a:xfrm>
             <a:off x="6254496" y="4407408"/>
+            <a:ext cx="5705856" cy="256032"/>
+          </a:xfrm>
+          <a:prstGeom prst="rect">
+            <a:avLst/>
+          </a:prstGeom>
+          <a:solidFill>
+            <a:srgbClr val="F9FAFB"/>
+          </a:solidFill>
+          <a:ln>
+            <a:noFill/>
+          </a:ln>
+        </p:spPr>
+        <p:style>
+          <a:lnRef idx="1">
+            <a:schemeClr val="accent1"/>
+          </a:lnRef>
+          <a:fillRef idx="3">
+            <a:schemeClr val="accent1"/>
+          </a:fillRef>
+          <a:effectRef idx="2">
+            <a:schemeClr val="accent1"/>
+          </a:effectRef>
+          <a:fontRef idx="minor">
+            <a:schemeClr val="lt1"/>
+          </a:fontRef>
+        </p:style>
+        <p:txBody>
+          <a:bodyPr rtlCol="0" anchor="ctr"/>
+          <a:lstStyle/>
+          <a:p>
+            <a:pPr algn="ctr"/>
+          </a:p>
+        </p:txBody>
+      </p:sp>
+      <p:sp>
+        <p:nvSpPr>
+          <p:cNvPr id="182" name="TextBox 181"/>
+          <p:cNvSpPr txBox="1"/>
+          <p:nvPr/>
+        </p:nvSpPr>
+        <p:spPr>
+          <a:xfrm>
+            <a:off x="6254496" y="4425696"/>
+            <a:ext cx="411480" cy="237744"/>
+          </a:xfrm>
+          <a:prstGeom prst="rect">
+            <a:avLst/>
+          </a:prstGeom>
+          <a:noFill/>
+        </p:spPr>
+        <p:txBody>
+          <a:bodyPr wrap="none">
+            <a:spAutoFit/>
+          </a:bodyPr>
+          <a:lstStyle/>
+          <a:p>
+            <a:pPr algn="ctr">
+              <a:defRPr sz="950" b="1">
+                <a:solidFill>
+                  <a:srgbClr val="6B7280"/>
+                </a:solidFill>
+                <a:latin typeface="Calibri"/>
+              </a:defRPr>
+            </a:pPr>
+            <a:r>
+              <a:t>34</a:t>
+            </a:r>
+          </a:p>
+        </p:txBody>
+      </p:sp>
+      <p:sp>
+        <p:nvSpPr>
+          <p:cNvPr id="183" name="TextBox 182"/>
+          <p:cNvSpPr txBox="1"/>
+          <p:nvPr/>
+        </p:nvSpPr>
+        <p:spPr>
+          <a:xfrm>
+            <a:off x="6665976" y="4425696"/>
+            <a:ext cx="1920240" cy="237744"/>
+          </a:xfrm>
+          <a:prstGeom prst="rect">
+            <a:avLst/>
+          </a:prstGeom>
+          <a:noFill/>
+        </p:spPr>
+        <p:txBody>
+          <a:bodyPr wrap="none">
+            <a:spAutoFit/>
+          </a:bodyPr>
+          <a:lstStyle/>
+          <a:p>
+            <a:pPr algn="l">
+              <a:defRPr sz="950" b="1">
+                <a:solidFill>
+                  <a:srgbClr val="111827"/>
+                </a:solidFill>
+                <a:latin typeface="Calibri"/>
+              </a:defRPr>
+            </a:pPr>
+            <a:r>
+              <a:t>Michael Su</a:t>
+            </a:r>
+          </a:p>
+        </p:txBody>
+      </p:sp>
+      <p:sp>
+        <p:nvSpPr>
+          <p:cNvPr id="184" name="TextBox 183"/>
+          <p:cNvSpPr txBox="1"/>
+          <p:nvPr/>
+        </p:nvSpPr>
+        <p:spPr>
+          <a:xfrm>
+            <a:off x="8586216" y="4425696"/>
+            <a:ext cx="2459736" cy="237744"/>
+          </a:xfrm>
+          <a:prstGeom prst="rect">
+            <a:avLst/>
+          </a:prstGeom>
+          <a:noFill/>
+        </p:spPr>
+        <p:txBody>
+          <a:bodyPr wrap="none">
+            <a:spAutoFit/>
+          </a:bodyPr>
+          <a:lstStyle/>
+          <a:p>
+            <a:pPr algn="l">
+              <a:defRPr sz="950" b="0">
+                <a:solidFill>
+                  <a:srgbClr val="6B7280"/>
+                </a:solidFill>
+                <a:latin typeface="Calibri"/>
+              </a:defRPr>
+            </a:pPr>
+            <a:r>
+              <a:t>Jtc Insurance Agency, Inc.</a:t>
+            </a:r>
+          </a:p>
+        </p:txBody>
+      </p:sp>
+      <p:sp>
+        <p:nvSpPr>
+          <p:cNvPr id="185" name="TextBox 184"/>
+          <p:cNvSpPr txBox="1"/>
+          <p:nvPr/>
+        </p:nvSpPr>
+        <p:spPr>
+          <a:xfrm>
+            <a:off x="11045952" y="4425696"/>
+            <a:ext cx="914400" cy="237744"/>
+          </a:xfrm>
+          <a:prstGeom prst="rect">
+            <a:avLst/>
+          </a:prstGeom>
+          <a:noFill/>
+        </p:spPr>
+        <p:txBody>
+          <a:bodyPr wrap="none">
+            <a:spAutoFit/>
+          </a:bodyPr>
+          <a:lstStyle/>
+          <a:p>
+            <a:pPr algn="ctr">
+              <a:defRPr sz="950" b="1">
+                <a:solidFill>
+                  <a:srgbClr val="111827"/>
+                </a:solidFill>
+                <a:latin typeface="Calibri"/>
+              </a:defRPr>
+            </a:pPr>
+            <a:r>
+              <a:t>$368K</a:t>
+            </a:r>
+          </a:p>
+        </p:txBody>
+      </p:sp>
+      <p:sp>
+        <p:nvSpPr>
+          <p:cNvPr id="186" name="Rectangle 185"/>
+          <p:cNvSpPr/>
+          <p:nvPr/>
+        </p:nvSpPr>
+        <p:spPr>
+          <a:xfrm>
+            <a:off x="6254496" y="4663440"/>
             <a:ext cx="5705856" cy="256032"/>
           </a:xfrm>
           <a:prstGeom prst="rect">
@@ -18522,13 +18709,13 @@
       </p:sp>
       <p:sp>
         <p:nvSpPr>
-          <p:cNvPr id="182" name="TextBox 181"/>
-          <p:cNvSpPr txBox="1"/>
-          <p:nvPr/>
-        </p:nvSpPr>
-        <p:spPr>
-          <a:xfrm>
-            <a:off x="6254496" y="4425696"/>
+          <p:cNvPr id="187" name="TextBox 186"/>
+          <p:cNvSpPr txBox="1"/>
+          <p:nvPr/>
+        </p:nvSpPr>
+        <p:spPr>
+          <a:xfrm>
+            <a:off x="6254496" y="4681728"/>
             <a:ext cx="411480" cy="237744"/>
           </a:xfrm>
           <a:prstGeom prst="rect">
@@ -18551,20 +18738,20 @@
               </a:defRPr>
             </a:pPr>
             <a:r>
-              <a:t>34</a:t>
-            </a:r>
-          </a:p>
-        </p:txBody>
-      </p:sp>
-      <p:sp>
-        <p:nvSpPr>
-          <p:cNvPr id="183" name="TextBox 182"/>
-          <p:cNvSpPr txBox="1"/>
-          <p:nvPr/>
-        </p:nvSpPr>
-        <p:spPr>
-          <a:xfrm>
-            <a:off x="6665976" y="4425696"/>
+              <a:t>35</a:t>
+            </a:r>
+          </a:p>
+        </p:txBody>
+      </p:sp>
+      <p:sp>
+        <p:nvSpPr>
+          <p:cNvPr id="188" name="TextBox 187"/>
+          <p:cNvSpPr txBox="1"/>
+          <p:nvPr/>
+        </p:nvSpPr>
+        <p:spPr>
+          <a:xfrm>
+            <a:off x="6665976" y="4681728"/>
             <a:ext cx="1920240" cy="237744"/>
           </a:xfrm>
           <a:prstGeom prst="rect">
@@ -18594,13 +18781,13 @@
       </p:sp>
       <p:sp>
         <p:nvSpPr>
-          <p:cNvPr id="184" name="TextBox 183"/>
-          <p:cNvSpPr txBox="1"/>
-          <p:nvPr/>
-        </p:nvSpPr>
-        <p:spPr>
-          <a:xfrm>
-            <a:off x="8586216" y="4425696"/>
+          <p:cNvPr id="189" name="TextBox 188"/>
+          <p:cNvSpPr txBox="1"/>
+          <p:nvPr/>
+        </p:nvSpPr>
+        <p:spPr>
+          <a:xfrm>
+            <a:off x="8586216" y="4681728"/>
             <a:ext cx="2459736" cy="237744"/>
           </a:xfrm>
           <a:prstGeom prst="rect">
@@ -18630,13 +18817,13 @@
       </p:sp>
       <p:sp>
         <p:nvSpPr>
-          <p:cNvPr id="185" name="TextBox 184"/>
-          <p:cNvSpPr txBox="1"/>
-          <p:nvPr/>
-        </p:nvSpPr>
-        <p:spPr>
-          <a:xfrm>
-            <a:off x="11045952" y="4425696"/>
+          <p:cNvPr id="190" name="TextBox 189"/>
+          <p:cNvSpPr txBox="1"/>
+          <p:nvPr/>
+        </p:nvSpPr>
+        <p:spPr>
+          <a:xfrm>
+            <a:off x="11045952" y="4681728"/>
             <a:ext cx="914400" cy="237744"/>
           </a:xfrm>
           <a:prstGeom prst="rect">
@@ -18666,13 +18853,200 @@
       </p:sp>
       <p:sp>
         <p:nvSpPr>
-          <p:cNvPr id="186" name="Rectangle 185"/>
+          <p:cNvPr id="191" name="Rectangle 190"/>
           <p:cNvSpPr/>
           <p:nvPr/>
         </p:nvSpPr>
         <p:spPr>
           <a:xfrm>
-            <a:off x="6254496" y="4663440"/>
+            <a:off x="6254496" y="4919472"/>
+            <a:ext cx="5705856" cy="256032"/>
+          </a:xfrm>
+          <a:prstGeom prst="rect">
+            <a:avLst/>
+          </a:prstGeom>
+          <a:solidFill>
+            <a:srgbClr val="F9FAFB"/>
+          </a:solidFill>
+          <a:ln>
+            <a:noFill/>
+          </a:ln>
+        </p:spPr>
+        <p:style>
+          <a:lnRef idx="1">
+            <a:schemeClr val="accent1"/>
+          </a:lnRef>
+          <a:fillRef idx="3">
+            <a:schemeClr val="accent1"/>
+          </a:fillRef>
+          <a:effectRef idx="2">
+            <a:schemeClr val="accent1"/>
+          </a:effectRef>
+          <a:fontRef idx="minor">
+            <a:schemeClr val="lt1"/>
+          </a:fontRef>
+        </p:style>
+        <p:txBody>
+          <a:bodyPr rtlCol="0" anchor="ctr"/>
+          <a:lstStyle/>
+          <a:p>
+            <a:pPr algn="ctr"/>
+          </a:p>
+        </p:txBody>
+      </p:sp>
+      <p:sp>
+        <p:nvSpPr>
+          <p:cNvPr id="192" name="TextBox 191"/>
+          <p:cNvSpPr txBox="1"/>
+          <p:nvPr/>
+        </p:nvSpPr>
+        <p:spPr>
+          <a:xfrm>
+            <a:off x="6254496" y="4937760"/>
+            <a:ext cx="411480" cy="237744"/>
+          </a:xfrm>
+          <a:prstGeom prst="rect">
+            <a:avLst/>
+          </a:prstGeom>
+          <a:noFill/>
+        </p:spPr>
+        <p:txBody>
+          <a:bodyPr wrap="none">
+            <a:spAutoFit/>
+          </a:bodyPr>
+          <a:lstStyle/>
+          <a:p>
+            <a:pPr algn="ctr">
+              <a:defRPr sz="950" b="1">
+                <a:solidFill>
+                  <a:srgbClr val="6B7280"/>
+                </a:solidFill>
+                <a:latin typeface="Calibri"/>
+              </a:defRPr>
+            </a:pPr>
+            <a:r>
+              <a:t>36</a:t>
+            </a:r>
+          </a:p>
+        </p:txBody>
+      </p:sp>
+      <p:sp>
+        <p:nvSpPr>
+          <p:cNvPr id="193" name="TextBox 192"/>
+          <p:cNvSpPr txBox="1"/>
+          <p:nvPr/>
+        </p:nvSpPr>
+        <p:spPr>
+          <a:xfrm>
+            <a:off x="6665976" y="4937760"/>
+            <a:ext cx="1920240" cy="237744"/>
+          </a:xfrm>
+          <a:prstGeom prst="rect">
+            <a:avLst/>
+          </a:prstGeom>
+          <a:noFill/>
+        </p:spPr>
+        <p:txBody>
+          <a:bodyPr wrap="none">
+            <a:spAutoFit/>
+          </a:bodyPr>
+          <a:lstStyle/>
+          <a:p>
+            <a:pPr algn="l">
+              <a:defRPr sz="950" b="1">
+                <a:solidFill>
+                  <a:srgbClr val="111827"/>
+                </a:solidFill>
+                <a:latin typeface="Calibri"/>
+              </a:defRPr>
+            </a:pPr>
+            <a:r>
+              <a:t>Ibrahim Mammo</a:t>
+            </a:r>
+          </a:p>
+        </p:txBody>
+      </p:sp>
+      <p:sp>
+        <p:nvSpPr>
+          <p:cNvPr id="194" name="TextBox 193"/>
+          <p:cNvSpPr txBox="1"/>
+          <p:nvPr/>
+        </p:nvSpPr>
+        <p:spPr>
+          <a:xfrm>
+            <a:off x="8586216" y="4937760"/>
+            <a:ext cx="2459736" cy="237744"/>
+          </a:xfrm>
+          <a:prstGeom prst="rect">
+            <a:avLst/>
+          </a:prstGeom>
+          <a:noFill/>
+        </p:spPr>
+        <p:txBody>
+          <a:bodyPr wrap="none">
+            <a:spAutoFit/>
+          </a:bodyPr>
+          <a:lstStyle/>
+          <a:p>
+            <a:pPr algn="l">
+              <a:defRPr sz="950" b="0">
+                <a:solidFill>
+                  <a:srgbClr val="6B7280"/>
+                </a:solidFill>
+                <a:latin typeface="Calibri"/>
+              </a:defRPr>
+            </a:pPr>
+            <a:r>
+              <a:t>Surefire Insurance Agency Corp.</a:t>
+            </a:r>
+          </a:p>
+        </p:txBody>
+      </p:sp>
+      <p:sp>
+        <p:nvSpPr>
+          <p:cNvPr id="195" name="TextBox 194"/>
+          <p:cNvSpPr txBox="1"/>
+          <p:nvPr/>
+        </p:nvSpPr>
+        <p:spPr>
+          <a:xfrm>
+            <a:off x="11045952" y="4937760"/>
+            <a:ext cx="914400" cy="237744"/>
+          </a:xfrm>
+          <a:prstGeom prst="rect">
+            <a:avLst/>
+          </a:prstGeom>
+          <a:noFill/>
+        </p:spPr>
+        <p:txBody>
+          <a:bodyPr wrap="none">
+            <a:spAutoFit/>
+          </a:bodyPr>
+          <a:lstStyle/>
+          <a:p>
+            <a:pPr algn="ctr">
+              <a:defRPr sz="950" b="1">
+                <a:solidFill>
+                  <a:srgbClr val="111827"/>
+                </a:solidFill>
+                <a:latin typeface="Calibri"/>
+              </a:defRPr>
+            </a:pPr>
+            <a:r>
+              <a:t>$365K</a:t>
+            </a:r>
+          </a:p>
+        </p:txBody>
+      </p:sp>
+      <p:sp>
+        <p:nvSpPr>
+          <p:cNvPr id="196" name="Rectangle 195"/>
+          <p:cNvSpPr/>
+          <p:nvPr/>
+        </p:nvSpPr>
+        <p:spPr>
+          <a:xfrm>
+            <a:off x="6254496" y="5175504"/>
             <a:ext cx="5705856" cy="256032"/>
           </a:xfrm>
           <a:prstGeom prst="rect">
@@ -18709,13 +19083,13 @@
       </p:sp>
       <p:sp>
         <p:nvSpPr>
-          <p:cNvPr id="187" name="TextBox 186"/>
-          <p:cNvSpPr txBox="1"/>
-          <p:nvPr/>
-        </p:nvSpPr>
-        <p:spPr>
-          <a:xfrm>
-            <a:off x="6254496" y="4681728"/>
+          <p:cNvPr id="197" name="TextBox 196"/>
+          <p:cNvSpPr txBox="1"/>
+          <p:nvPr/>
+        </p:nvSpPr>
+        <p:spPr>
+          <a:xfrm>
+            <a:off x="6254496" y="5193792"/>
             <a:ext cx="411480" cy="237744"/>
           </a:xfrm>
           <a:prstGeom prst="rect">
@@ -18738,20 +19112,20 @@
               </a:defRPr>
             </a:pPr>
             <a:r>
-              <a:t>35</a:t>
-            </a:r>
-          </a:p>
-        </p:txBody>
-      </p:sp>
-      <p:sp>
-        <p:nvSpPr>
-          <p:cNvPr id="188" name="TextBox 187"/>
-          <p:cNvSpPr txBox="1"/>
-          <p:nvPr/>
-        </p:nvSpPr>
-        <p:spPr>
-          <a:xfrm>
-            <a:off x="6665976" y="4681728"/>
+              <a:t>37</a:t>
+            </a:r>
+          </a:p>
+        </p:txBody>
+      </p:sp>
+      <p:sp>
+        <p:nvSpPr>
+          <p:cNvPr id="198" name="TextBox 197"/>
+          <p:cNvSpPr txBox="1"/>
+          <p:nvPr/>
+        </p:nvSpPr>
+        <p:spPr>
+          <a:xfrm>
+            <a:off x="6665976" y="5193792"/>
             <a:ext cx="1920240" cy="237744"/>
           </a:xfrm>
           <a:prstGeom prst="rect">
@@ -18774,20 +19148,20 @@
               </a:defRPr>
             </a:pPr>
             <a:r>
-              <a:t>Ibrahim Mammo</a:t>
-            </a:r>
-          </a:p>
-        </p:txBody>
-      </p:sp>
-      <p:sp>
-        <p:nvSpPr>
-          <p:cNvPr id="189" name="TextBox 188"/>
-          <p:cNvSpPr txBox="1"/>
-          <p:nvPr/>
-        </p:nvSpPr>
-        <p:spPr>
-          <a:xfrm>
-            <a:off x="8586216" y="4681728"/>
+              <a:t>Patricia Galindoparedes</a:t>
+            </a:r>
+          </a:p>
+        </p:txBody>
+      </p:sp>
+      <p:sp>
+        <p:nvSpPr>
+          <p:cNvPr id="199" name="TextBox 198"/>
+          <p:cNvSpPr txBox="1"/>
+          <p:nvPr/>
+        </p:nvSpPr>
+        <p:spPr>
+          <a:xfrm>
+            <a:off x="8586216" y="5193792"/>
             <a:ext cx="2459736" cy="237744"/>
           </a:xfrm>
           <a:prstGeom prst="rect">
@@ -18810,20 +19184,20 @@
               </a:defRPr>
             </a:pPr>
             <a:r>
-              <a:t>Surefire Insurance Agency Corp.</a:t>
-            </a:r>
-          </a:p>
-        </p:txBody>
-      </p:sp>
-      <p:sp>
-        <p:nvSpPr>
-          <p:cNvPr id="190" name="TextBox 189"/>
-          <p:cNvSpPr txBox="1"/>
-          <p:nvPr/>
-        </p:nvSpPr>
-        <p:spPr>
-          <a:xfrm>
-            <a:off x="11045952" y="4681728"/>
+              <a:t>Call Patty Insurance Services</a:t>
+            </a:r>
+          </a:p>
+        </p:txBody>
+      </p:sp>
+      <p:sp>
+        <p:nvSpPr>
+          <p:cNvPr id="200" name="TextBox 199"/>
+          <p:cNvSpPr txBox="1"/>
+          <p:nvPr/>
+        </p:nvSpPr>
+        <p:spPr>
+          <a:xfrm>
+            <a:off x="11045952" y="5193792"/>
             <a:ext cx="914400" cy="237744"/>
           </a:xfrm>
           <a:prstGeom prst="rect">
@@ -18846,20 +19220,20 @@
               </a:defRPr>
             </a:pPr>
             <a:r>
-              <a:t>$365K</a:t>
-            </a:r>
-          </a:p>
-        </p:txBody>
-      </p:sp>
-      <p:sp>
-        <p:nvSpPr>
-          <p:cNvPr id="191" name="Rectangle 190"/>
+              <a:t>$361K</a:t>
+            </a:r>
+          </a:p>
+        </p:txBody>
+      </p:sp>
+      <p:sp>
+        <p:nvSpPr>
+          <p:cNvPr id="201" name="Rectangle 200"/>
           <p:cNvSpPr/>
           <p:nvPr/>
         </p:nvSpPr>
         <p:spPr>
           <a:xfrm>
-            <a:off x="6254496" y="4919472"/>
+            <a:off x="6254496" y="5431536"/>
             <a:ext cx="5705856" cy="256032"/>
           </a:xfrm>
           <a:prstGeom prst="rect">
@@ -18896,13 +19270,13 @@
       </p:sp>
       <p:sp>
         <p:nvSpPr>
-          <p:cNvPr id="192" name="TextBox 191"/>
-          <p:cNvSpPr txBox="1"/>
-          <p:nvPr/>
-        </p:nvSpPr>
-        <p:spPr>
-          <a:xfrm>
-            <a:off x="6254496" y="4937760"/>
+          <p:cNvPr id="202" name="TextBox 201"/>
+          <p:cNvSpPr txBox="1"/>
+          <p:nvPr/>
+        </p:nvSpPr>
+        <p:spPr>
+          <a:xfrm>
+            <a:off x="6254496" y="5449824"/>
             <a:ext cx="411480" cy="237744"/>
           </a:xfrm>
           <a:prstGeom prst="rect">
@@ -18925,20 +19299,20 @@
               </a:defRPr>
             </a:pPr>
             <a:r>
-              <a:t>36</a:t>
-            </a:r>
-          </a:p>
-        </p:txBody>
-      </p:sp>
-      <p:sp>
-        <p:nvSpPr>
-          <p:cNvPr id="193" name="TextBox 192"/>
-          <p:cNvSpPr txBox="1"/>
-          <p:nvPr/>
-        </p:nvSpPr>
-        <p:spPr>
-          <a:xfrm>
-            <a:off x="6665976" y="4937760"/>
+              <a:t>38</a:t>
+            </a:r>
+          </a:p>
+        </p:txBody>
+      </p:sp>
+      <p:sp>
+        <p:nvSpPr>
+          <p:cNvPr id="203" name="TextBox 202"/>
+          <p:cNvSpPr txBox="1"/>
+          <p:nvPr/>
+        </p:nvSpPr>
+        <p:spPr>
+          <a:xfrm>
+            <a:off x="6665976" y="5449824"/>
             <a:ext cx="1920240" cy="237744"/>
           </a:xfrm>
           <a:prstGeom prst="rect">
@@ -18961,20 +19335,20 @@
               </a:defRPr>
             </a:pPr>
             <a:r>
-              <a:t>Patricia Galindoparedes</a:t>
-            </a:r>
-          </a:p>
-        </p:txBody>
-      </p:sp>
-      <p:sp>
-        <p:nvSpPr>
-          <p:cNvPr id="194" name="TextBox 193"/>
-          <p:cNvSpPr txBox="1"/>
-          <p:nvPr/>
-        </p:nvSpPr>
-        <p:spPr>
-          <a:xfrm>
-            <a:off x="8586216" y="4937760"/>
+              <a:t>Kurtis Gautz</a:t>
+            </a:r>
+          </a:p>
+        </p:txBody>
+      </p:sp>
+      <p:sp>
+        <p:nvSpPr>
+          <p:cNvPr id="204" name="TextBox 203"/>
+          <p:cNvSpPr txBox="1"/>
+          <p:nvPr/>
+        </p:nvSpPr>
+        <p:spPr>
+          <a:xfrm>
+            <a:off x="8586216" y="5449824"/>
             <a:ext cx="2459736" cy="237744"/>
           </a:xfrm>
           <a:prstGeom prst="rect">
@@ -18997,20 +19371,20 @@
               </a:defRPr>
             </a:pPr>
             <a:r>
-              <a:t>Call Patty Insurance Services</a:t>
-            </a:r>
-          </a:p>
-        </p:txBody>
-      </p:sp>
-      <p:sp>
-        <p:nvSpPr>
-          <p:cNvPr id="195" name="TextBox 194"/>
-          <p:cNvSpPr txBox="1"/>
-          <p:nvPr/>
-        </p:nvSpPr>
-        <p:spPr>
-          <a:xfrm>
-            <a:off x="11045952" y="4937760"/>
+              <a:t>CRC Insurance Services, Inc</a:t>
+            </a:r>
+          </a:p>
+        </p:txBody>
+      </p:sp>
+      <p:sp>
+        <p:nvSpPr>
+          <p:cNvPr id="205" name="TextBox 204"/>
+          <p:cNvSpPr txBox="1"/>
+          <p:nvPr/>
+        </p:nvSpPr>
+        <p:spPr>
+          <a:xfrm>
+            <a:off x="11045952" y="5449824"/>
             <a:ext cx="914400" cy="237744"/>
           </a:xfrm>
           <a:prstGeom prst="rect">
@@ -19033,27 +19407,27 @@
               </a:defRPr>
             </a:pPr>
             <a:r>
-              <a:t>$361K</a:t>
-            </a:r>
-          </a:p>
-        </p:txBody>
-      </p:sp>
-      <p:sp>
-        <p:nvSpPr>
-          <p:cNvPr id="196" name="Rectangle 195"/>
+              <a:t>$352K</a:t>
+            </a:r>
+          </a:p>
+        </p:txBody>
+      </p:sp>
+      <p:sp>
+        <p:nvSpPr>
+          <p:cNvPr id="206" name="Rectangle 205"/>
           <p:cNvSpPr/>
           <p:nvPr/>
         </p:nvSpPr>
         <p:spPr>
           <a:xfrm>
-            <a:off x="6254496" y="5175504"/>
+            <a:off x="6254496" y="5687568"/>
             <a:ext cx="5705856" cy="256032"/>
           </a:xfrm>
           <a:prstGeom prst="rect">
             <a:avLst/>
           </a:prstGeom>
           <a:solidFill>
-            <a:srgbClr val="FFFFFF"/>
+            <a:srgbClr val="D1FAE5"/>
           </a:solidFill>
           <a:ln>
             <a:noFill/>
@@ -19083,13 +19457,13 @@
       </p:sp>
       <p:sp>
         <p:nvSpPr>
-          <p:cNvPr id="197" name="TextBox 196"/>
-          <p:cNvSpPr txBox="1"/>
-          <p:nvPr/>
-        </p:nvSpPr>
-        <p:spPr>
-          <a:xfrm>
-            <a:off x="6254496" y="5193792"/>
+          <p:cNvPr id="207" name="TextBox 206"/>
+          <p:cNvSpPr txBox="1"/>
+          <p:nvPr/>
+        </p:nvSpPr>
+        <p:spPr>
+          <a:xfrm>
+            <a:off x="6254496" y="5705856"/>
             <a:ext cx="411480" cy="237744"/>
           </a:xfrm>
           <a:prstGeom prst="rect">
@@ -19112,20 +19486,20 @@
               </a:defRPr>
             </a:pPr>
             <a:r>
-              <a:t>37</a:t>
-            </a:r>
-          </a:p>
-        </p:txBody>
-      </p:sp>
-      <p:sp>
-        <p:nvSpPr>
-          <p:cNvPr id="198" name="TextBox 197"/>
-          <p:cNvSpPr txBox="1"/>
-          <p:nvPr/>
-        </p:nvSpPr>
-        <p:spPr>
-          <a:xfrm>
-            <a:off x="6665976" y="5193792"/>
+              <a:t>39</a:t>
+            </a:r>
+          </a:p>
+        </p:txBody>
+      </p:sp>
+      <p:sp>
+        <p:nvSpPr>
+          <p:cNvPr id="208" name="TextBox 207"/>
+          <p:cNvSpPr txBox="1"/>
+          <p:nvPr/>
+        </p:nvSpPr>
+        <p:spPr>
+          <a:xfrm>
+            <a:off x="6665976" y="5705856"/>
             <a:ext cx="1920240" cy="237744"/>
           </a:xfrm>
           <a:prstGeom prst="rect">
@@ -19148,20 +19522,20 @@
               </a:defRPr>
             </a:pPr>
             <a:r>
-              <a:t>Kurtis Gautz</a:t>
-            </a:r>
-          </a:p>
-        </p:txBody>
-      </p:sp>
-      <p:sp>
-        <p:nvSpPr>
-          <p:cNvPr id="199" name="TextBox 198"/>
-          <p:cNvSpPr txBox="1"/>
-          <p:nvPr/>
-        </p:nvSpPr>
-        <p:spPr>
-          <a:xfrm>
-            <a:off x="8586216" y="5193792"/>
+              <a:t>Api_User Api_User</a:t>
+            </a:r>
+          </a:p>
+        </p:txBody>
+      </p:sp>
+      <p:sp>
+        <p:nvSpPr>
+          <p:cNvPr id="209" name="TextBox 208"/>
+          <p:cNvSpPr txBox="1"/>
+          <p:nvPr/>
+        </p:nvSpPr>
+        <p:spPr>
+          <a:xfrm>
+            <a:off x="8586216" y="5705856"/>
             <a:ext cx="2459736" cy="237744"/>
           </a:xfrm>
           <a:prstGeom prst="rect">
@@ -19184,20 +19558,20 @@
               </a:defRPr>
             </a:pPr>
             <a:r>
-              <a:t>CRC Insurance Services, Inc</a:t>
-            </a:r>
-          </a:p>
-        </p:txBody>
-      </p:sp>
-      <p:sp>
-        <p:nvSpPr>
-          <p:cNvPr id="200" name="TextBox 199"/>
-          <p:cNvSpPr txBox="1"/>
-          <p:nvPr/>
-        </p:nvSpPr>
-        <p:spPr>
-          <a:xfrm>
-            <a:off x="11045952" y="5193792"/>
+              <a:t>Insurance4Truckers LLC</a:t>
+            </a:r>
+          </a:p>
+        </p:txBody>
+      </p:sp>
+      <p:sp>
+        <p:nvSpPr>
+          <p:cNvPr id="210" name="TextBox 209"/>
+          <p:cNvSpPr txBox="1"/>
+          <p:nvPr/>
+        </p:nvSpPr>
+        <p:spPr>
+          <a:xfrm>
+            <a:off x="11045952" y="5705856"/>
             <a:ext cx="914400" cy="237744"/>
           </a:xfrm>
           <a:prstGeom prst="rect">
@@ -19220,20 +19594,20 @@
               </a:defRPr>
             </a:pPr>
             <a:r>
-              <a:t>$352K</a:t>
-            </a:r>
-          </a:p>
-        </p:txBody>
-      </p:sp>
-      <p:sp>
-        <p:nvSpPr>
-          <p:cNvPr id="201" name="Rectangle 200"/>
+              <a:t>$344K</a:t>
+            </a:r>
+          </a:p>
+        </p:txBody>
+      </p:sp>
+      <p:sp>
+        <p:nvSpPr>
+          <p:cNvPr id="211" name="Rectangle 210"/>
           <p:cNvSpPr/>
           <p:nvPr/>
         </p:nvSpPr>
         <p:spPr>
           <a:xfrm>
-            <a:off x="6254496" y="5431536"/>
+            <a:off x="6254496" y="5943600"/>
             <a:ext cx="5705856" cy="256032"/>
           </a:xfrm>
           <a:prstGeom prst="rect">
@@ -19270,13 +19644,13 @@
       </p:sp>
       <p:sp>
         <p:nvSpPr>
-          <p:cNvPr id="202" name="TextBox 201"/>
-          <p:cNvSpPr txBox="1"/>
-          <p:nvPr/>
-        </p:nvSpPr>
-        <p:spPr>
-          <a:xfrm>
-            <a:off x="6254496" y="5449824"/>
+          <p:cNvPr id="212" name="TextBox 211"/>
+          <p:cNvSpPr txBox="1"/>
+          <p:nvPr/>
+        </p:nvSpPr>
+        <p:spPr>
+          <a:xfrm>
+            <a:off x="6254496" y="5961888"/>
             <a:ext cx="411480" cy="237744"/>
           </a:xfrm>
           <a:prstGeom prst="rect">
@@ -19299,20 +19673,20 @@
               </a:defRPr>
             </a:pPr>
             <a:r>
-              <a:t>38</a:t>
-            </a:r>
-          </a:p>
-        </p:txBody>
-      </p:sp>
-      <p:sp>
-        <p:nvSpPr>
-          <p:cNvPr id="203" name="TextBox 202"/>
-          <p:cNvSpPr txBox="1"/>
-          <p:nvPr/>
-        </p:nvSpPr>
-        <p:spPr>
-          <a:xfrm>
-            <a:off x="6665976" y="5449824"/>
+              <a:t>40</a:t>
+            </a:r>
+          </a:p>
+        </p:txBody>
+      </p:sp>
+      <p:sp>
+        <p:nvSpPr>
+          <p:cNvPr id="213" name="TextBox 212"/>
+          <p:cNvSpPr txBox="1"/>
+          <p:nvPr/>
+        </p:nvSpPr>
+        <p:spPr>
+          <a:xfrm>
+            <a:off x="6665976" y="5961888"/>
             <a:ext cx="1920240" cy="237744"/>
           </a:xfrm>
           <a:prstGeom prst="rect">
@@ -19342,13 +19716,13 @@
       </p:sp>
       <p:sp>
         <p:nvSpPr>
-          <p:cNvPr id="204" name="TextBox 203"/>
-          <p:cNvSpPr txBox="1"/>
-          <p:nvPr/>
-        </p:nvSpPr>
-        <p:spPr>
-          <a:xfrm>
-            <a:off x="8586216" y="5449824"/>
+          <p:cNvPr id="214" name="TextBox 213"/>
+          <p:cNvSpPr txBox="1"/>
+          <p:nvPr/>
+        </p:nvSpPr>
+        <p:spPr>
+          <a:xfrm>
+            <a:off x="8586216" y="5961888"/>
             <a:ext cx="2459736" cy="237744"/>
           </a:xfrm>
           <a:prstGeom prst="rect">
@@ -19378,380 +19752,6 @@
       </p:sp>
       <p:sp>
         <p:nvSpPr>
-          <p:cNvPr id="205" name="TextBox 204"/>
-          <p:cNvSpPr txBox="1"/>
-          <p:nvPr/>
-        </p:nvSpPr>
-        <p:spPr>
-          <a:xfrm>
-            <a:off x="11045952" y="5449824"/>
-            <a:ext cx="914400" cy="237744"/>
-          </a:xfrm>
-          <a:prstGeom prst="rect">
-            <a:avLst/>
-          </a:prstGeom>
-          <a:noFill/>
-        </p:spPr>
-        <p:txBody>
-          <a:bodyPr wrap="none">
-            <a:spAutoFit/>
-          </a:bodyPr>
-          <a:lstStyle/>
-          <a:p>
-            <a:pPr algn="ctr">
-              <a:defRPr sz="950" b="1">
-                <a:solidFill>
-                  <a:srgbClr val="111827"/>
-                </a:solidFill>
-                <a:latin typeface="Calibri"/>
-              </a:defRPr>
-            </a:pPr>
-            <a:r>
-              <a:t>$341K</a:t>
-            </a:r>
-          </a:p>
-        </p:txBody>
-      </p:sp>
-      <p:sp>
-        <p:nvSpPr>
-          <p:cNvPr id="206" name="Rectangle 205"/>
-          <p:cNvSpPr/>
-          <p:nvPr/>
-        </p:nvSpPr>
-        <p:spPr>
-          <a:xfrm>
-            <a:off x="6254496" y="5687568"/>
-            <a:ext cx="5705856" cy="256032"/>
-          </a:xfrm>
-          <a:prstGeom prst="rect">
-            <a:avLst/>
-          </a:prstGeom>
-          <a:solidFill>
-            <a:srgbClr val="FFFFFF"/>
-          </a:solidFill>
-          <a:ln>
-            <a:noFill/>
-          </a:ln>
-        </p:spPr>
-        <p:style>
-          <a:lnRef idx="1">
-            <a:schemeClr val="accent1"/>
-          </a:lnRef>
-          <a:fillRef idx="3">
-            <a:schemeClr val="accent1"/>
-          </a:fillRef>
-          <a:effectRef idx="2">
-            <a:schemeClr val="accent1"/>
-          </a:effectRef>
-          <a:fontRef idx="minor">
-            <a:schemeClr val="lt1"/>
-          </a:fontRef>
-        </p:style>
-        <p:txBody>
-          <a:bodyPr rtlCol="0" anchor="ctr"/>
-          <a:lstStyle/>
-          <a:p>
-            <a:pPr algn="ctr"/>
-          </a:p>
-        </p:txBody>
-      </p:sp>
-      <p:sp>
-        <p:nvSpPr>
-          <p:cNvPr id="207" name="TextBox 206"/>
-          <p:cNvSpPr txBox="1"/>
-          <p:nvPr/>
-        </p:nvSpPr>
-        <p:spPr>
-          <a:xfrm>
-            <a:off x="6254496" y="5705856"/>
-            <a:ext cx="411480" cy="237744"/>
-          </a:xfrm>
-          <a:prstGeom prst="rect">
-            <a:avLst/>
-          </a:prstGeom>
-          <a:noFill/>
-        </p:spPr>
-        <p:txBody>
-          <a:bodyPr wrap="none">
-            <a:spAutoFit/>
-          </a:bodyPr>
-          <a:lstStyle/>
-          <a:p>
-            <a:pPr algn="ctr">
-              <a:defRPr sz="950" b="1">
-                <a:solidFill>
-                  <a:srgbClr val="6B7280"/>
-                </a:solidFill>
-                <a:latin typeface="Calibri"/>
-              </a:defRPr>
-            </a:pPr>
-            <a:r>
-              <a:t>39</a:t>
-            </a:r>
-          </a:p>
-        </p:txBody>
-      </p:sp>
-      <p:sp>
-        <p:nvSpPr>
-          <p:cNvPr id="208" name="TextBox 207"/>
-          <p:cNvSpPr txBox="1"/>
-          <p:nvPr/>
-        </p:nvSpPr>
-        <p:spPr>
-          <a:xfrm>
-            <a:off x="6665976" y="5705856"/>
-            <a:ext cx="1920240" cy="237744"/>
-          </a:xfrm>
-          <a:prstGeom prst="rect">
-            <a:avLst/>
-          </a:prstGeom>
-          <a:noFill/>
-        </p:spPr>
-        <p:txBody>
-          <a:bodyPr wrap="none">
-            <a:spAutoFit/>
-          </a:bodyPr>
-          <a:lstStyle/>
-          <a:p>
-            <a:pPr algn="l">
-              <a:defRPr sz="950" b="1">
-                <a:solidFill>
-                  <a:srgbClr val="111827"/>
-                </a:solidFill>
-                <a:latin typeface="Calibri"/>
-              </a:defRPr>
-            </a:pPr>
-            <a:r>
-              <a:t>Omar Elmanzalawy</a:t>
-            </a:r>
-          </a:p>
-        </p:txBody>
-      </p:sp>
-      <p:sp>
-        <p:nvSpPr>
-          <p:cNvPr id="209" name="TextBox 208"/>
-          <p:cNvSpPr txBox="1"/>
-          <p:nvPr/>
-        </p:nvSpPr>
-        <p:spPr>
-          <a:xfrm>
-            <a:off x="8586216" y="5705856"/>
-            <a:ext cx="2459736" cy="237744"/>
-          </a:xfrm>
-          <a:prstGeom prst="rect">
-            <a:avLst/>
-          </a:prstGeom>
-          <a:noFill/>
-        </p:spPr>
-        <p:txBody>
-          <a:bodyPr wrap="none">
-            <a:spAutoFit/>
-          </a:bodyPr>
-          <a:lstStyle/>
-          <a:p>
-            <a:pPr algn="l">
-              <a:defRPr sz="950" b="0">
-                <a:solidFill>
-                  <a:srgbClr val="6B7280"/>
-                </a:solidFill>
-                <a:latin typeface="Calibri"/>
-              </a:defRPr>
-            </a:pPr>
-            <a:r>
-              <a:t>First Connect Insurance</a:t>
-            </a:r>
-          </a:p>
-        </p:txBody>
-      </p:sp>
-      <p:sp>
-        <p:nvSpPr>
-          <p:cNvPr id="210" name="TextBox 209"/>
-          <p:cNvSpPr txBox="1"/>
-          <p:nvPr/>
-        </p:nvSpPr>
-        <p:spPr>
-          <a:xfrm>
-            <a:off x="11045952" y="5705856"/>
-            <a:ext cx="914400" cy="237744"/>
-          </a:xfrm>
-          <a:prstGeom prst="rect">
-            <a:avLst/>
-          </a:prstGeom>
-          <a:noFill/>
-        </p:spPr>
-        <p:txBody>
-          <a:bodyPr wrap="none">
-            <a:spAutoFit/>
-          </a:bodyPr>
-          <a:lstStyle/>
-          <a:p>
-            <a:pPr algn="ctr">
-              <a:defRPr sz="950" b="1">
-                <a:solidFill>
-                  <a:srgbClr val="111827"/>
-                </a:solidFill>
-                <a:latin typeface="Calibri"/>
-              </a:defRPr>
-            </a:pPr>
-            <a:r>
-              <a:t>$339K</a:t>
-            </a:r>
-          </a:p>
-        </p:txBody>
-      </p:sp>
-      <p:sp>
-        <p:nvSpPr>
-          <p:cNvPr id="211" name="Rectangle 210"/>
-          <p:cNvSpPr/>
-          <p:nvPr/>
-        </p:nvSpPr>
-        <p:spPr>
-          <a:xfrm>
-            <a:off x="6254496" y="5943600"/>
-            <a:ext cx="5705856" cy="256032"/>
-          </a:xfrm>
-          <a:prstGeom prst="rect">
-            <a:avLst/>
-          </a:prstGeom>
-          <a:solidFill>
-            <a:srgbClr val="F9FAFB"/>
-          </a:solidFill>
-          <a:ln>
-            <a:noFill/>
-          </a:ln>
-        </p:spPr>
-        <p:style>
-          <a:lnRef idx="1">
-            <a:schemeClr val="accent1"/>
-          </a:lnRef>
-          <a:fillRef idx="3">
-            <a:schemeClr val="accent1"/>
-          </a:fillRef>
-          <a:effectRef idx="2">
-            <a:schemeClr val="accent1"/>
-          </a:effectRef>
-          <a:fontRef idx="minor">
-            <a:schemeClr val="lt1"/>
-          </a:fontRef>
-        </p:style>
-        <p:txBody>
-          <a:bodyPr rtlCol="0" anchor="ctr"/>
-          <a:lstStyle/>
-          <a:p>
-            <a:pPr algn="ctr"/>
-          </a:p>
-        </p:txBody>
-      </p:sp>
-      <p:sp>
-        <p:nvSpPr>
-          <p:cNvPr id="212" name="TextBox 211"/>
-          <p:cNvSpPr txBox="1"/>
-          <p:nvPr/>
-        </p:nvSpPr>
-        <p:spPr>
-          <a:xfrm>
-            <a:off x="6254496" y="5961888"/>
-            <a:ext cx="411480" cy="237744"/>
-          </a:xfrm>
-          <a:prstGeom prst="rect">
-            <a:avLst/>
-          </a:prstGeom>
-          <a:noFill/>
-        </p:spPr>
-        <p:txBody>
-          <a:bodyPr wrap="none">
-            <a:spAutoFit/>
-          </a:bodyPr>
-          <a:lstStyle/>
-          <a:p>
-            <a:pPr algn="ctr">
-              <a:defRPr sz="950" b="1">
-                <a:solidFill>
-                  <a:srgbClr val="6B7280"/>
-                </a:solidFill>
-                <a:latin typeface="Calibri"/>
-              </a:defRPr>
-            </a:pPr>
-            <a:r>
-              <a:t>40</a:t>
-            </a:r>
-          </a:p>
-        </p:txBody>
-      </p:sp>
-      <p:sp>
-        <p:nvSpPr>
-          <p:cNvPr id="213" name="TextBox 212"/>
-          <p:cNvSpPr txBox="1"/>
-          <p:nvPr/>
-        </p:nvSpPr>
-        <p:spPr>
-          <a:xfrm>
-            <a:off x="6665976" y="5961888"/>
-            <a:ext cx="1920240" cy="237744"/>
-          </a:xfrm>
-          <a:prstGeom prst="rect">
-            <a:avLst/>
-          </a:prstGeom>
-          <a:noFill/>
-        </p:spPr>
-        <p:txBody>
-          <a:bodyPr wrap="none">
-            <a:spAutoFit/>
-          </a:bodyPr>
-          <a:lstStyle/>
-          <a:p>
-            <a:pPr algn="l">
-              <a:defRPr sz="950" b="1">
-                <a:solidFill>
-                  <a:srgbClr val="111827"/>
-                </a:solidFill>
-                <a:latin typeface="Calibri"/>
-              </a:defRPr>
-            </a:pPr>
-            <a:r>
-              <a:t>Venizelos Papadopulos</a:t>
-            </a:r>
-          </a:p>
-        </p:txBody>
-      </p:sp>
-      <p:sp>
-        <p:nvSpPr>
-          <p:cNvPr id="214" name="TextBox 213"/>
-          <p:cNvSpPr txBox="1"/>
-          <p:nvPr/>
-        </p:nvSpPr>
-        <p:spPr>
-          <a:xfrm>
-            <a:off x="8586216" y="5961888"/>
-            <a:ext cx="2459736" cy="237744"/>
-          </a:xfrm>
-          <a:prstGeom prst="rect">
-            <a:avLst/>
-          </a:prstGeom>
-          <a:noFill/>
-        </p:spPr>
-        <p:txBody>
-          <a:bodyPr wrap="none">
-            <a:spAutoFit/>
-          </a:bodyPr>
-          <a:lstStyle/>
-          <a:p>
-            <a:pPr algn="l">
-              <a:defRPr sz="950" b="0">
-                <a:solidFill>
-                  <a:srgbClr val="6B7280"/>
-                </a:solidFill>
-                <a:latin typeface="Calibri"/>
-              </a:defRPr>
-            </a:pPr>
-            <a:r>
-              <a:t>Exclusive Financial Services, Inc</a:t>
-            </a:r>
-          </a:p>
-        </p:txBody>
-      </p:sp>
-      <p:sp>
-        <p:nvSpPr>
           <p:cNvPr id="215" name="TextBox 214"/>
           <p:cNvSpPr txBox="1"/>
           <p:nvPr/>
@@ -19781,7 +19781,7 @@
               </a:defRPr>
             </a:pPr>
             <a:r>
-              <a:t>$334K</a:t>
+              <a:t>$341K</a:t>
             </a:r>
           </a:p>
         </p:txBody>
@@ -34143,7 +34143,7 @@
               </a:defRPr>
             </a:pPr>
             <a:r>
-              <a:t>$4.2M</a:t>
+              <a:t>$4.3M</a:t>
             </a:r>
           </a:p>
         </p:txBody>
@@ -34978,7 +34978,7 @@
               </a:defRPr>
             </a:pPr>
             <a:r>
-              <a:t>$3.7M</a:t>
+              <a:t>$3.8M</a:t>
             </a:r>
           </a:p>
         </p:txBody>
@@ -35417,7 +35417,7 @@
               </a:defRPr>
             </a:pPr>
             <a:r>
-              <a:t>$1.9M</a:t>
+              <a:t>$2.0M</a:t>
             </a:r>
           </a:p>
         </p:txBody>
@@ -36685,13 +36685,13 @@
             <a:pPr algn="ctr">
               <a:defRPr sz="950" b="0">
                 <a:solidFill>
-                  <a:srgbClr val="111827"/>
-                </a:solidFill>
-                <a:latin typeface="Calibri"/>
-              </a:defRPr>
-            </a:pPr>
-            <a:r>
-              <a:t>$0</a:t>
+                  <a:srgbClr val="059669"/>
+                </a:solidFill>
+                <a:latin typeface="Calibri"/>
+              </a:defRPr>
+            </a:pPr>
+            <a:r>
+              <a:t>$3K</a:t>
             </a:r>
           </a:p>
         </p:txBody>
@@ -36727,7 +36727,7 @@
               </a:defRPr>
             </a:pPr>
             <a:r>
-              <a:t>$271K</a:t>
+              <a:t>$273K</a:t>
             </a:r>
           </a:p>
         </p:txBody>
@@ -38447,7 +38447,7 @@
               </a:defRPr>
             </a:pPr>
             <a:r>
-              <a:t>$8.4M</a:t>
+              <a:t>$8.6M</a:t>
             </a:r>
           </a:p>
         </p:txBody>

</xml_diff>